<commit_message>
Block 3: add missing icons and arrows from reference images
Co-Authored-By: Claude Opus 5.5 <noreply@anthropic.com>
Claude-Session: https://claude.ai/code/session_01B4DF2G5N9mx6ELDfutDHLb
</commit_message>
<xml_diff>
--- a/block3_UE_SIM_testing.pptx
+++ b/block3_UE_SIM_testing.pptx
@@ -9127,36 +9127,40 @@
           </a:p>
         </p:txBody>
       </p:sp>
-      <p:sp>
-        <p:nvSpPr>
-          <p:cNvPr id="106" name="Shape 67"/>
-          <p:cNvSpPr/>
-          <p:nvPr/>
-        </p:nvSpPr>
-        <p:spPr>
-          <a:xfrm>
-            <a:off x="3913632" y="3837737"/>
-            <a:ext cx="59436" cy="59436"/>
-          </a:xfrm>
-          <a:prstGeom prst="ellipse">
-            <a:avLst/>
-          </a:prstGeom>
-          <a:solidFill>
-            <a:srgbClr val="FF812A"/>
-          </a:solidFill>
-          <a:ln/>
-        </p:spPr>
-      </p:sp>
-      <p:sp>
-        <p:nvSpPr>
-          <p:cNvPr id="107" name="Text 68"/>
-          <p:cNvSpPr txBox="1"/>
-          <p:nvPr/>
-        </p:nvSpPr>
-        <p:spPr>
-          <a:xfrm>
-            <a:off x="4041648" y="3785616"/>
-            <a:ext cx="1344168" cy="164592"/>
+      <p:pic>
+        <p:nvPicPr>
+          <p:cNvPr id="106" name="Image 37" descr="preencoded.png">    </p:cNvPr>
+          <p:cNvPicPr>
+            <a:picLocks noChangeAspect="1"/>
+          </p:cNvPicPr>
+          <p:nvPr/>
+        </p:nvPicPr>
+        <p:blipFill>
+          <a:blip r:embed="rId38"/>
+          <a:stretch>
+            <a:fillRect/>
+          </a:stretch>
+        </p:blipFill>
+        <p:spPr>
+          <a:xfrm>
+            <a:off x="3877056" y="3781044"/>
+            <a:ext cx="173736" cy="173736"/>
+          </a:xfrm>
+          <a:prstGeom prst="rect">
+            <a:avLst/>
+          </a:prstGeom>
+        </p:spPr>
+      </p:pic>
+      <p:sp>
+        <p:nvSpPr>
+          <p:cNvPr id="107" name="Text 67"/>
+          <p:cNvSpPr txBox="1"/>
+          <p:nvPr/>
+        </p:nvSpPr>
+        <p:spPr>
+          <a:xfrm>
+            <a:off x="4151376" y="3785616"/>
+            <a:ext cx="1280160" cy="164592"/>
           </a:xfrm>
           <a:prstGeom prst="rect">
             <a:avLst/>
@@ -9189,36 +9193,40 @@
           </a:p>
         </p:txBody>
       </p:sp>
-      <p:sp>
-        <p:nvSpPr>
-          <p:cNvPr id="108" name="Shape 69"/>
-          <p:cNvSpPr/>
-          <p:nvPr/>
-        </p:nvSpPr>
-        <p:spPr>
-          <a:xfrm>
-            <a:off x="3913632" y="4002329"/>
-            <a:ext cx="59436" cy="59436"/>
-          </a:xfrm>
-          <a:prstGeom prst="ellipse">
-            <a:avLst/>
-          </a:prstGeom>
-          <a:solidFill>
-            <a:srgbClr val="FF812A"/>
-          </a:solidFill>
-          <a:ln/>
-        </p:spPr>
-      </p:sp>
-      <p:sp>
-        <p:nvSpPr>
-          <p:cNvPr id="109" name="Text 70"/>
-          <p:cNvSpPr txBox="1"/>
-          <p:nvPr/>
-        </p:nvSpPr>
-        <p:spPr>
-          <a:xfrm>
-            <a:off x="4041648" y="3950208"/>
-            <a:ext cx="1344168" cy="164592"/>
+      <p:pic>
+        <p:nvPicPr>
+          <p:cNvPr id="108" name="Image 38" descr="preencoded.png">    </p:cNvPr>
+          <p:cNvPicPr>
+            <a:picLocks noChangeAspect="1"/>
+          </p:cNvPicPr>
+          <p:nvPr/>
+        </p:nvPicPr>
+        <p:blipFill>
+          <a:blip r:embed="rId39"/>
+          <a:stretch>
+            <a:fillRect/>
+          </a:stretch>
+        </p:blipFill>
+        <p:spPr>
+          <a:xfrm>
+            <a:off x="3877056" y="3945636"/>
+            <a:ext cx="173736" cy="173736"/>
+          </a:xfrm>
+          <a:prstGeom prst="rect">
+            <a:avLst/>
+          </a:prstGeom>
+        </p:spPr>
+      </p:pic>
+      <p:sp>
+        <p:nvSpPr>
+          <p:cNvPr id="109" name="Text 68"/>
+          <p:cNvSpPr txBox="1"/>
+          <p:nvPr/>
+        </p:nvSpPr>
+        <p:spPr>
+          <a:xfrm>
+            <a:off x="4151376" y="3950208"/>
+            <a:ext cx="1280160" cy="164592"/>
           </a:xfrm>
           <a:prstGeom prst="rect">
             <a:avLst/>
@@ -9251,36 +9259,40 @@
           </a:p>
         </p:txBody>
       </p:sp>
-      <p:sp>
-        <p:nvSpPr>
-          <p:cNvPr id="110" name="Shape 71"/>
-          <p:cNvSpPr/>
-          <p:nvPr/>
-        </p:nvSpPr>
-        <p:spPr>
-          <a:xfrm>
-            <a:off x="3913632" y="4166921"/>
-            <a:ext cx="59436" cy="59436"/>
-          </a:xfrm>
-          <a:prstGeom prst="ellipse">
-            <a:avLst/>
-          </a:prstGeom>
-          <a:solidFill>
-            <a:srgbClr val="FF812A"/>
-          </a:solidFill>
-          <a:ln/>
-        </p:spPr>
-      </p:sp>
-      <p:sp>
-        <p:nvSpPr>
-          <p:cNvPr id="111" name="Text 72"/>
-          <p:cNvSpPr txBox="1"/>
-          <p:nvPr/>
-        </p:nvSpPr>
-        <p:spPr>
-          <a:xfrm>
-            <a:off x="4041648" y="4114800"/>
-            <a:ext cx="1344168" cy="164592"/>
+      <p:pic>
+        <p:nvPicPr>
+          <p:cNvPr id="110" name="Image 39" descr="preencoded.png">    </p:cNvPr>
+          <p:cNvPicPr>
+            <a:picLocks noChangeAspect="1"/>
+          </p:cNvPicPr>
+          <p:nvPr/>
+        </p:nvPicPr>
+        <p:blipFill>
+          <a:blip r:embed="rId40"/>
+          <a:stretch>
+            <a:fillRect/>
+          </a:stretch>
+        </p:blipFill>
+        <p:spPr>
+          <a:xfrm>
+            <a:off x="3877056" y="4110228"/>
+            <a:ext cx="173736" cy="173736"/>
+          </a:xfrm>
+          <a:prstGeom prst="rect">
+            <a:avLst/>
+          </a:prstGeom>
+        </p:spPr>
+      </p:pic>
+      <p:sp>
+        <p:nvSpPr>
+          <p:cNvPr id="111" name="Text 69"/>
+          <p:cNvSpPr txBox="1"/>
+          <p:nvPr/>
+        </p:nvSpPr>
+        <p:spPr>
+          <a:xfrm>
+            <a:off x="4151376" y="4114800"/>
+            <a:ext cx="1280160" cy="164592"/>
           </a:xfrm>
           <a:prstGeom prst="rect">
             <a:avLst/>
@@ -9313,36 +9325,40 @@
           </a:p>
         </p:txBody>
       </p:sp>
-      <p:sp>
-        <p:nvSpPr>
-          <p:cNvPr id="112" name="Shape 73"/>
-          <p:cNvSpPr/>
-          <p:nvPr/>
-        </p:nvSpPr>
-        <p:spPr>
-          <a:xfrm>
-            <a:off x="3913632" y="4331513"/>
-            <a:ext cx="59436" cy="59436"/>
-          </a:xfrm>
-          <a:prstGeom prst="ellipse">
-            <a:avLst/>
-          </a:prstGeom>
-          <a:solidFill>
-            <a:srgbClr val="FF812A"/>
-          </a:solidFill>
-          <a:ln/>
-        </p:spPr>
-      </p:sp>
-      <p:sp>
-        <p:nvSpPr>
-          <p:cNvPr id="113" name="Text 74"/>
-          <p:cNvSpPr txBox="1"/>
-          <p:nvPr/>
-        </p:nvSpPr>
-        <p:spPr>
-          <a:xfrm>
-            <a:off x="4041648" y="4279392"/>
-            <a:ext cx="1344168" cy="164592"/>
+      <p:pic>
+        <p:nvPicPr>
+          <p:cNvPr id="112" name="Image 40" descr="preencoded.png">    </p:cNvPr>
+          <p:cNvPicPr>
+            <a:picLocks noChangeAspect="1"/>
+          </p:cNvPicPr>
+          <p:nvPr/>
+        </p:nvPicPr>
+        <p:blipFill>
+          <a:blip r:embed="rId41"/>
+          <a:stretch>
+            <a:fillRect/>
+          </a:stretch>
+        </p:blipFill>
+        <p:spPr>
+          <a:xfrm>
+            <a:off x="3877056" y="4274820"/>
+            <a:ext cx="173736" cy="173736"/>
+          </a:xfrm>
+          <a:prstGeom prst="rect">
+            <a:avLst/>
+          </a:prstGeom>
+        </p:spPr>
+      </p:pic>
+      <p:sp>
+        <p:nvSpPr>
+          <p:cNvPr id="113" name="Text 70"/>
+          <p:cNvSpPr txBox="1"/>
+          <p:nvPr/>
+        </p:nvSpPr>
+        <p:spPr>
+          <a:xfrm>
+            <a:off x="4151376" y="4279392"/>
+            <a:ext cx="1280160" cy="164592"/>
           </a:xfrm>
           <a:prstGeom prst="rect">
             <a:avLst/>
@@ -9375,36 +9391,40 @@
           </a:p>
         </p:txBody>
       </p:sp>
-      <p:sp>
-        <p:nvSpPr>
-          <p:cNvPr id="114" name="Shape 75"/>
-          <p:cNvSpPr/>
-          <p:nvPr/>
-        </p:nvSpPr>
-        <p:spPr>
-          <a:xfrm>
-            <a:off x="3913632" y="4496105"/>
-            <a:ext cx="59436" cy="59436"/>
-          </a:xfrm>
-          <a:prstGeom prst="ellipse">
-            <a:avLst/>
-          </a:prstGeom>
-          <a:solidFill>
-            <a:srgbClr val="FF812A"/>
-          </a:solidFill>
-          <a:ln/>
-        </p:spPr>
-      </p:sp>
-      <p:sp>
-        <p:nvSpPr>
-          <p:cNvPr id="115" name="Text 76"/>
-          <p:cNvSpPr txBox="1"/>
-          <p:nvPr/>
-        </p:nvSpPr>
-        <p:spPr>
-          <a:xfrm>
-            <a:off x="4041648" y="4443984"/>
-            <a:ext cx="1344168" cy="164592"/>
+      <p:pic>
+        <p:nvPicPr>
+          <p:cNvPr id="114" name="Image 41" descr="preencoded.png">    </p:cNvPr>
+          <p:cNvPicPr>
+            <a:picLocks noChangeAspect="1"/>
+          </p:cNvPicPr>
+          <p:nvPr/>
+        </p:nvPicPr>
+        <p:blipFill>
+          <a:blip r:embed="rId42"/>
+          <a:stretch>
+            <a:fillRect/>
+          </a:stretch>
+        </p:blipFill>
+        <p:spPr>
+          <a:xfrm>
+            <a:off x="3877056" y="4439412"/>
+            <a:ext cx="173736" cy="173736"/>
+          </a:xfrm>
+          <a:prstGeom prst="rect">
+            <a:avLst/>
+          </a:prstGeom>
+        </p:spPr>
+      </p:pic>
+      <p:sp>
+        <p:nvSpPr>
+          <p:cNvPr id="115" name="Text 71"/>
+          <p:cNvSpPr txBox="1"/>
+          <p:nvPr/>
+        </p:nvSpPr>
+        <p:spPr>
+          <a:xfrm>
+            <a:off x="4151376" y="4443984"/>
+            <a:ext cx="1280160" cy="164592"/>
           </a:xfrm>
           <a:prstGeom prst="rect">
             <a:avLst/>
@@ -9437,36 +9457,40 @@
           </a:p>
         </p:txBody>
       </p:sp>
-      <p:sp>
-        <p:nvSpPr>
-          <p:cNvPr id="116" name="Shape 77"/>
-          <p:cNvSpPr/>
-          <p:nvPr/>
-        </p:nvSpPr>
-        <p:spPr>
-          <a:xfrm>
-            <a:off x="3913632" y="4660697"/>
-            <a:ext cx="59436" cy="59436"/>
-          </a:xfrm>
-          <a:prstGeom prst="ellipse">
-            <a:avLst/>
-          </a:prstGeom>
-          <a:solidFill>
-            <a:srgbClr val="FF812A"/>
-          </a:solidFill>
-          <a:ln/>
-        </p:spPr>
-      </p:sp>
-      <p:sp>
-        <p:nvSpPr>
-          <p:cNvPr id="117" name="Text 78"/>
-          <p:cNvSpPr txBox="1"/>
-          <p:nvPr/>
-        </p:nvSpPr>
-        <p:spPr>
-          <a:xfrm>
-            <a:off x="4041648" y="4608576"/>
-            <a:ext cx="1344168" cy="164592"/>
+      <p:pic>
+        <p:nvPicPr>
+          <p:cNvPr id="116" name="Image 42" descr="preencoded.png">    </p:cNvPr>
+          <p:cNvPicPr>
+            <a:picLocks noChangeAspect="1"/>
+          </p:cNvPicPr>
+          <p:nvPr/>
+        </p:nvPicPr>
+        <p:blipFill>
+          <a:blip r:embed="rId43"/>
+          <a:stretch>
+            <a:fillRect/>
+          </a:stretch>
+        </p:blipFill>
+        <p:spPr>
+          <a:xfrm>
+            <a:off x="3877056" y="4604004"/>
+            <a:ext cx="173736" cy="173736"/>
+          </a:xfrm>
+          <a:prstGeom prst="rect">
+            <a:avLst/>
+          </a:prstGeom>
+        </p:spPr>
+      </p:pic>
+      <p:sp>
+        <p:nvSpPr>
+          <p:cNvPr id="117" name="Text 72"/>
+          <p:cNvSpPr txBox="1"/>
+          <p:nvPr/>
+        </p:nvSpPr>
+        <p:spPr>
+          <a:xfrm>
+            <a:off x="4151376" y="4608576"/>
+            <a:ext cx="1280160" cy="164592"/>
           </a:xfrm>
           <a:prstGeom prst="rect">
             <a:avLst/>
@@ -9501,7 +9525,55 @@
       </p:sp>
       <p:sp>
         <p:nvSpPr>
-          <p:cNvPr id="118" name="Shape 79"/>
+          <p:cNvPr id="118" name="Shape 73"/>
+          <p:cNvSpPr/>
+          <p:nvPr/>
+        </p:nvSpPr>
+        <p:spPr>
+          <a:xfrm>
+            <a:off x="3584448" y="4192524"/>
+            <a:ext cx="164592" cy="0"/>
+          </a:xfrm>
+          <a:prstGeom prst="line">
+            <a:avLst/>
+          </a:prstGeom>
+          <a:noFill/>
+          <a:ln w="25400">
+            <a:solidFill>
+              <a:srgbClr val="FF812A"/>
+            </a:solidFill>
+            <a:prstDash val="solid"/>
+            <a:tailEnd type="triangle"/>
+          </a:ln>
+        </p:spPr>
+      </p:sp>
+      <p:sp>
+        <p:nvSpPr>
+          <p:cNvPr id="119" name="Shape 74"/>
+          <p:cNvSpPr/>
+          <p:nvPr/>
+        </p:nvSpPr>
+        <p:spPr>
+          <a:xfrm flipH="1">
+            <a:off x="8442655" y="4192524"/>
+            <a:ext cx="164592" cy="0"/>
+          </a:xfrm>
+          <a:prstGeom prst="line">
+            <a:avLst/>
+          </a:prstGeom>
+          <a:noFill/>
+          <a:ln w="25400">
+            <a:solidFill>
+              <a:srgbClr val="FF812A"/>
+            </a:solidFill>
+            <a:prstDash val="solid"/>
+            <a:tailEnd type="triangle"/>
+          </a:ln>
+        </p:spPr>
+      </p:sp>
+      <p:sp>
+        <p:nvSpPr>
+          <p:cNvPr id="120" name="Shape 75"/>
           <p:cNvSpPr/>
           <p:nvPr/>
         </p:nvSpPr>
@@ -9524,7 +9596,7 @@
       </p:sp>
       <p:sp>
         <p:nvSpPr>
-          <p:cNvPr id="119" name="Text 80"/>
+          <p:cNvPr id="121" name="Text 76"/>
           <p:cNvSpPr txBox="1"/>
           <p:nvPr/>
         </p:nvSpPr>
@@ -9566,7 +9638,7 @@
       </p:sp>
       <p:sp>
         <p:nvSpPr>
-          <p:cNvPr id="120" name="Shape 81"/>
+          <p:cNvPr id="122" name="Shape 77"/>
           <p:cNvSpPr/>
           <p:nvPr/>
         </p:nvSpPr>
@@ -9586,7 +9658,7 @@
       </p:sp>
       <p:sp>
         <p:nvSpPr>
-          <p:cNvPr id="121" name="Text 82"/>
+          <p:cNvPr id="123" name="Text 78"/>
           <p:cNvSpPr txBox="1"/>
           <p:nvPr/>
         </p:nvSpPr>
@@ -9628,7 +9700,7 @@
       </p:sp>
       <p:sp>
         <p:nvSpPr>
-          <p:cNvPr id="122" name="Shape 83"/>
+          <p:cNvPr id="124" name="Shape 79"/>
           <p:cNvSpPr/>
           <p:nvPr/>
         </p:nvSpPr>
@@ -9648,7 +9720,7 @@
       </p:sp>
       <p:sp>
         <p:nvSpPr>
-          <p:cNvPr id="123" name="Text 84"/>
+          <p:cNvPr id="125" name="Text 80"/>
           <p:cNvSpPr txBox="1"/>
           <p:nvPr/>
         </p:nvSpPr>
@@ -9690,7 +9762,7 @@
       </p:sp>
       <p:sp>
         <p:nvSpPr>
-          <p:cNvPr id="124" name="Shape 85"/>
+          <p:cNvPr id="126" name="Shape 81"/>
           <p:cNvSpPr/>
           <p:nvPr/>
         </p:nvSpPr>
@@ -9710,7 +9782,7 @@
       </p:sp>
       <p:sp>
         <p:nvSpPr>
-          <p:cNvPr id="125" name="Text 86"/>
+          <p:cNvPr id="127" name="Text 82"/>
           <p:cNvSpPr txBox="1"/>
           <p:nvPr/>
         </p:nvSpPr>
@@ -9752,7 +9824,7 @@
       </p:sp>
       <p:sp>
         <p:nvSpPr>
-          <p:cNvPr id="126" name="Shape 87"/>
+          <p:cNvPr id="128" name="Shape 83"/>
           <p:cNvSpPr/>
           <p:nvPr/>
         </p:nvSpPr>
@@ -9772,7 +9844,7 @@
       </p:sp>
       <p:sp>
         <p:nvSpPr>
-          <p:cNvPr id="127" name="Text 88"/>
+          <p:cNvPr id="129" name="Text 84"/>
           <p:cNvSpPr txBox="1"/>
           <p:nvPr/>
         </p:nvSpPr>
@@ -9814,7 +9886,7 @@
       </p:sp>
       <p:sp>
         <p:nvSpPr>
-          <p:cNvPr id="128" name="Shape 89"/>
+          <p:cNvPr id="130" name="Shape 85"/>
           <p:cNvSpPr/>
           <p:nvPr/>
         </p:nvSpPr>
@@ -9834,7 +9906,7 @@
       </p:sp>
       <p:sp>
         <p:nvSpPr>
-          <p:cNvPr id="129" name="Text 90"/>
+          <p:cNvPr id="131" name="Text 86"/>
           <p:cNvSpPr txBox="1"/>
           <p:nvPr/>
         </p:nvSpPr>
@@ -9876,7 +9948,7 @@
       </p:sp>
       <p:sp>
         <p:nvSpPr>
-          <p:cNvPr id="130" name="Shape 91"/>
+          <p:cNvPr id="132" name="Shape 87"/>
           <p:cNvSpPr/>
           <p:nvPr/>
         </p:nvSpPr>
@@ -9896,7 +9968,7 @@
       </p:sp>
       <p:sp>
         <p:nvSpPr>
-          <p:cNvPr id="131" name="Text 92"/>
+          <p:cNvPr id="133" name="Text 88"/>
           <p:cNvSpPr txBox="1"/>
           <p:nvPr/>
         </p:nvSpPr>
@@ -9938,7 +10010,7 @@
       </p:sp>
       <p:sp>
         <p:nvSpPr>
-          <p:cNvPr id="132" name="Shape 93"/>
+          <p:cNvPr id="134" name="Shape 89"/>
           <p:cNvSpPr/>
           <p:nvPr/>
         </p:nvSpPr>
@@ -9958,7 +10030,7 @@
       </p:sp>
       <p:sp>
         <p:nvSpPr>
-          <p:cNvPr id="133" name="Text 94"/>
+          <p:cNvPr id="135" name="Text 90"/>
           <p:cNvSpPr txBox="1"/>
           <p:nvPr/>
         </p:nvSpPr>
@@ -10000,7 +10072,7 @@
       </p:sp>
       <p:sp>
         <p:nvSpPr>
-          <p:cNvPr id="134" name="Shape 95"/>
+          <p:cNvPr id="136" name="Shape 91"/>
           <p:cNvSpPr/>
           <p:nvPr/>
         </p:nvSpPr>
@@ -10020,7 +10092,7 @@
       </p:sp>
       <p:sp>
         <p:nvSpPr>
-          <p:cNvPr id="135" name="Text 96"/>
+          <p:cNvPr id="137" name="Text 92"/>
           <p:cNvSpPr txBox="1"/>
           <p:nvPr/>
         </p:nvSpPr>
@@ -10062,7 +10134,7 @@
       </p:sp>
       <p:sp>
         <p:nvSpPr>
-          <p:cNvPr id="136" name="Shape 97"/>
+          <p:cNvPr id="138" name="Shape 93"/>
           <p:cNvSpPr/>
           <p:nvPr/>
         </p:nvSpPr>
@@ -10082,7 +10154,7 @@
       </p:sp>
       <p:sp>
         <p:nvSpPr>
-          <p:cNvPr id="137" name="Text 98"/>
+          <p:cNvPr id="139" name="Text 94"/>
           <p:cNvSpPr txBox="1"/>
           <p:nvPr/>
         </p:nvSpPr>
@@ -10124,7 +10196,7 @@
       </p:sp>
       <p:sp>
         <p:nvSpPr>
-          <p:cNvPr id="138" name="Shape 99"/>
+          <p:cNvPr id="140" name="Shape 95"/>
           <p:cNvSpPr/>
           <p:nvPr/>
         </p:nvSpPr>
@@ -10144,7 +10216,7 @@
       </p:sp>
       <p:sp>
         <p:nvSpPr>
-          <p:cNvPr id="139" name="Text 100"/>
+          <p:cNvPr id="141" name="Text 96"/>
           <p:cNvSpPr txBox="1"/>
           <p:nvPr/>
         </p:nvSpPr>
@@ -10186,7 +10258,7 @@
       </p:sp>
       <p:sp>
         <p:nvSpPr>
-          <p:cNvPr id="140" name="Shape 101"/>
+          <p:cNvPr id="142" name="Shape 97"/>
           <p:cNvSpPr/>
           <p:nvPr/>
         </p:nvSpPr>
@@ -10213,7 +10285,7 @@
       </p:sp>
       <p:sp>
         <p:nvSpPr>
-          <p:cNvPr id="141" name="Text 102"/>
+          <p:cNvPr id="143" name="Text 98"/>
           <p:cNvSpPr txBox="1"/>
           <p:nvPr/>
         </p:nvSpPr>
@@ -10255,426 +10327,7 @@
       </p:sp>
       <p:pic>
         <p:nvPicPr>
-          <p:cNvPr id="142" name="Image 37" descr="preencoded.png">    </p:cNvPr>
-          <p:cNvPicPr>
-            <a:picLocks noChangeAspect="1"/>
-          </p:cNvPicPr>
-          <p:nvPr/>
-        </p:nvPicPr>
-        <p:blipFill>
-          <a:blip r:embed="rId38"/>
-          <a:stretch>
-            <a:fillRect/>
-          </a:stretch>
-        </p:blipFill>
-        <p:spPr>
-          <a:xfrm>
-            <a:off x="822960" y="5303520"/>
-            <a:ext cx="182880" cy="182880"/>
-          </a:xfrm>
-          <a:prstGeom prst="rect">
-            <a:avLst/>
-          </a:prstGeom>
-        </p:spPr>
-      </p:pic>
-      <p:sp>
-        <p:nvSpPr>
-          <p:cNvPr id="143" name="Text 103"/>
-          <p:cNvSpPr txBox="1"/>
-          <p:nvPr/>
-        </p:nvSpPr>
-        <p:spPr>
-          <a:xfrm>
-            <a:off x="1097280" y="5303520"/>
-            <a:ext cx="4846320" cy="182880"/>
-          </a:xfrm>
-          <a:prstGeom prst="rect">
-            <a:avLst/>
-          </a:prstGeom>
-          <a:noFill/>
-          <a:ln/>
-        </p:spPr>
-        <p:txBody>
-          <a:bodyPr wrap="square" lIns="0" tIns="0" rIns="0" bIns="0" rtlCol="0" anchor="ctr"/>
-          <a:lstStyle/>
-          <a:p>
-            <a:pPr algn="l" indent="0" marL="0">
-              <a:lnSpc>
-                <a:spcPct val="95000"/>
-              </a:lnSpc>
-              <a:buNone/>
-            </a:pPr>
-            <a:r>
-              <a:rPr lang="en-US" sz="1000" dirty="0">
-                <a:solidFill>
-                  <a:srgbClr val="1F2937"/>
-                </a:solidFill>
-                <a:latin typeface="Bahnschrift SemiCondensed" pitchFamily="34" charset="0"/>
-                <a:ea typeface="Bahnschrift SemiCondensed" pitchFamily="34" charset="-122"/>
-                <a:cs typeface="Bahnschrift SemiCondensed" pitchFamily="34" charset="-120"/>
-              </a:rPr>
-              <a:t>UE не регистрируется</a:t>
-            </a:r>
-            <a:endParaRPr lang="en-US" sz="1000" dirty="0"/>
-          </a:p>
-        </p:txBody>
-      </p:sp>
-      <p:pic>
-        <p:nvPicPr>
-          <p:cNvPr id="144" name="Image 38" descr="preencoded.png">    </p:cNvPr>
-          <p:cNvPicPr>
-            <a:picLocks noChangeAspect="1"/>
-          </p:cNvPicPr>
-          <p:nvPr/>
-        </p:nvPicPr>
-        <p:blipFill>
-          <a:blip r:embed="rId39"/>
-          <a:stretch>
-            <a:fillRect/>
-          </a:stretch>
-        </p:blipFill>
-        <p:spPr>
-          <a:xfrm>
-            <a:off x="822960" y="5486400"/>
-            <a:ext cx="182880" cy="182880"/>
-          </a:xfrm>
-          <a:prstGeom prst="rect">
-            <a:avLst/>
-          </a:prstGeom>
-        </p:spPr>
-      </p:pic>
-      <p:sp>
-        <p:nvSpPr>
-          <p:cNvPr id="145" name="Text 104"/>
-          <p:cNvSpPr txBox="1"/>
-          <p:nvPr/>
-        </p:nvSpPr>
-        <p:spPr>
-          <a:xfrm>
-            <a:off x="1097280" y="5486400"/>
-            <a:ext cx="4846320" cy="182880"/>
-          </a:xfrm>
-          <a:prstGeom prst="rect">
-            <a:avLst/>
-          </a:prstGeom>
-          <a:noFill/>
-          <a:ln/>
-        </p:spPr>
-        <p:txBody>
-          <a:bodyPr wrap="square" lIns="0" tIns="0" rIns="0" bIns="0" rtlCol="0" anchor="ctr"/>
-          <a:lstStyle/>
-          <a:p>
-            <a:pPr algn="l" indent="0" marL="0">
-              <a:lnSpc>
-                <a:spcPct val="95000"/>
-              </a:lnSpc>
-              <a:buNone/>
-            </a:pPr>
-            <a:r>
-              <a:rPr lang="en-US" sz="1000" dirty="0">
-                <a:solidFill>
-                  <a:srgbClr val="1F2937"/>
-                </a:solidFill>
-                <a:latin typeface="Bahnschrift SemiCondensed" pitchFamily="34" charset="0"/>
-                <a:ea typeface="Bahnschrift SemiCondensed" pitchFamily="34" charset="-122"/>
-                <a:cs typeface="Bahnschrift SemiCondensed" pitchFamily="34" charset="-120"/>
-              </a:rPr>
-              <a:t>аутентификация не проходит</a:t>
-            </a:r>
-            <a:endParaRPr lang="en-US" sz="1000" dirty="0"/>
-          </a:p>
-        </p:txBody>
-      </p:sp>
-      <p:pic>
-        <p:nvPicPr>
-          <p:cNvPr id="146" name="Image 39" descr="preencoded.png">    </p:cNvPr>
-          <p:cNvPicPr>
-            <a:picLocks noChangeAspect="1"/>
-          </p:cNvPicPr>
-          <p:nvPr/>
-        </p:nvPicPr>
-        <p:blipFill>
-          <a:blip r:embed="rId40"/>
-          <a:stretch>
-            <a:fillRect/>
-          </a:stretch>
-        </p:blipFill>
-        <p:spPr>
-          <a:xfrm>
-            <a:off x="822960" y="5669280"/>
-            <a:ext cx="182880" cy="182880"/>
-          </a:xfrm>
-          <a:prstGeom prst="rect">
-            <a:avLst/>
-          </a:prstGeom>
-        </p:spPr>
-      </p:pic>
-      <p:sp>
-        <p:nvSpPr>
-          <p:cNvPr id="147" name="Text 105"/>
-          <p:cNvSpPr txBox="1"/>
-          <p:nvPr/>
-        </p:nvSpPr>
-        <p:spPr>
-          <a:xfrm>
-            <a:off x="1097280" y="5669280"/>
-            <a:ext cx="4846320" cy="182880"/>
-          </a:xfrm>
-          <a:prstGeom prst="rect">
-            <a:avLst/>
-          </a:prstGeom>
-          <a:noFill/>
-          <a:ln/>
-        </p:spPr>
-        <p:txBody>
-          <a:bodyPr wrap="square" lIns="0" tIns="0" rIns="0" bIns="0" rtlCol="0" anchor="ctr"/>
-          <a:lstStyle/>
-          <a:p>
-            <a:pPr algn="l" indent="0" marL="0">
-              <a:lnSpc>
-                <a:spcPct val="95000"/>
-              </a:lnSpc>
-              <a:buNone/>
-            </a:pPr>
-            <a:r>
-              <a:rPr lang="en-US" sz="1000" dirty="0">
-                <a:solidFill>
-                  <a:srgbClr val="1F2937"/>
-                </a:solidFill>
-                <a:latin typeface="Bahnschrift SemiCondensed" pitchFamily="34" charset="0"/>
-                <a:ea typeface="Bahnschrift SemiCondensed" pitchFamily="34" charset="-122"/>
-                <a:cs typeface="Bahnschrift SemiCondensed" pitchFamily="34" charset="-120"/>
-              </a:rPr>
-              <a:t>PDU Session отклоняется</a:t>
-            </a:r>
-            <a:endParaRPr lang="en-US" sz="1000" dirty="0"/>
-          </a:p>
-        </p:txBody>
-      </p:sp>
-      <p:pic>
-        <p:nvPicPr>
-          <p:cNvPr id="148" name="Image 40" descr="preencoded.png">    </p:cNvPr>
-          <p:cNvPicPr>
-            <a:picLocks noChangeAspect="1"/>
-          </p:cNvPicPr>
-          <p:nvPr/>
-        </p:nvPicPr>
-        <p:blipFill>
-          <a:blip r:embed="rId41"/>
-          <a:stretch>
-            <a:fillRect/>
-          </a:stretch>
-        </p:blipFill>
-        <p:spPr>
-          <a:xfrm>
-            <a:off x="822960" y="5852160"/>
-            <a:ext cx="182880" cy="182880"/>
-          </a:xfrm>
-          <a:prstGeom prst="rect">
-            <a:avLst/>
-          </a:prstGeom>
-        </p:spPr>
-      </p:pic>
-      <p:sp>
-        <p:nvSpPr>
-          <p:cNvPr id="149" name="Text 106"/>
-          <p:cNvSpPr txBox="1"/>
-          <p:nvPr/>
-        </p:nvSpPr>
-        <p:spPr>
-          <a:xfrm>
-            <a:off x="1097280" y="5852160"/>
-            <a:ext cx="4846320" cy="182880"/>
-          </a:xfrm>
-          <a:prstGeom prst="rect">
-            <a:avLst/>
-          </a:prstGeom>
-          <a:noFill/>
-          <a:ln/>
-        </p:spPr>
-        <p:txBody>
-          <a:bodyPr wrap="square" lIns="0" tIns="0" rIns="0" bIns="0" rtlCol="0" anchor="ctr"/>
-          <a:lstStyle/>
-          <a:p>
-            <a:pPr algn="l" indent="0" marL="0">
-              <a:lnSpc>
-                <a:spcPct val="95000"/>
-              </a:lnSpc>
-              <a:buNone/>
-            </a:pPr>
-            <a:r>
-              <a:rPr lang="en-US" sz="1000" dirty="0">
-                <a:solidFill>
-                  <a:srgbClr val="1F2937"/>
-                </a:solidFill>
-                <a:latin typeface="Bahnschrift SemiCondensed" pitchFamily="34" charset="0"/>
-                <a:ea typeface="Bahnschrift SemiCondensed" pitchFamily="34" charset="-122"/>
-                <a:cs typeface="Bahnschrift SemiCondensed" pitchFamily="34" charset="-120"/>
-              </a:rPr>
-              <a:t>роуминг не работает</a:t>
-            </a:r>
-            <a:endParaRPr lang="en-US" sz="1000" dirty="0"/>
-          </a:p>
-        </p:txBody>
-      </p:sp>
-      <p:sp>
-        <p:nvSpPr>
-          <p:cNvPr id="150" name="Shape 107"/>
-          <p:cNvSpPr/>
-          <p:nvPr/>
-        </p:nvSpPr>
-        <p:spPr>
-          <a:xfrm>
-            <a:off x="6095848" y="5340096"/>
-            <a:ext cx="0" cy="621792"/>
-          </a:xfrm>
-          <a:prstGeom prst="line">
-            <a:avLst/>
-          </a:prstGeom>
-          <a:noFill/>
-          <a:ln w="9525">
-            <a:solidFill>
-              <a:srgbClr val="7F7BEC"/>
-            </a:solidFill>
-            <a:prstDash val="dash"/>
-          </a:ln>
-        </p:spPr>
-      </p:sp>
-      <p:pic>
-        <p:nvPicPr>
-          <p:cNvPr id="151" name="Image 41" descr="preencoded.png">    </p:cNvPr>
-          <p:cNvPicPr>
-            <a:picLocks noChangeAspect="1"/>
-          </p:cNvPicPr>
-          <p:nvPr/>
-        </p:nvPicPr>
-        <p:blipFill>
-          <a:blip r:embed="rId42"/>
-          <a:stretch>
-            <a:fillRect/>
-          </a:stretch>
-        </p:blipFill>
-        <p:spPr>
-          <a:xfrm>
-            <a:off x="6370168" y="5303520"/>
-            <a:ext cx="182880" cy="182880"/>
-          </a:xfrm>
-          <a:prstGeom prst="rect">
-            <a:avLst/>
-          </a:prstGeom>
-        </p:spPr>
-      </p:pic>
-      <p:sp>
-        <p:nvSpPr>
-          <p:cNvPr id="152" name="Text 108"/>
-          <p:cNvSpPr txBox="1"/>
-          <p:nvPr/>
-        </p:nvSpPr>
-        <p:spPr>
-          <a:xfrm>
-            <a:off x="6644488" y="5303520"/>
-            <a:ext cx="5090008" cy="182880"/>
-          </a:xfrm>
-          <a:prstGeom prst="rect">
-            <a:avLst/>
-          </a:prstGeom>
-          <a:noFill/>
-          <a:ln/>
-        </p:spPr>
-        <p:txBody>
-          <a:bodyPr wrap="square" lIns="0" tIns="0" rIns="0" bIns="0" rtlCol="0" anchor="ctr"/>
-          <a:lstStyle/>
-          <a:p>
-            <a:pPr algn="l" indent="0" marL="0">
-              <a:lnSpc>
-                <a:spcPct val="95000"/>
-              </a:lnSpc>
-              <a:buNone/>
-            </a:pPr>
-            <a:r>
-              <a:rPr lang="en-US" sz="1000" dirty="0">
-                <a:solidFill>
-                  <a:srgbClr val="1F2937"/>
-                </a:solidFill>
-                <a:latin typeface="Bahnschrift SemiCondensed" pitchFamily="34" charset="0"/>
-                <a:ea typeface="Bahnschrift SemiCondensed" pitchFamily="34" charset="-122"/>
-                <a:cs typeface="Bahnschrift SemiCondensed" pitchFamily="34" charset="-120"/>
-              </a:rPr>
-              <a:t>IMS / VoLTE / VoNR не регистрируется</a:t>
-            </a:r>
-            <a:endParaRPr lang="en-US" sz="1000" dirty="0"/>
-          </a:p>
-        </p:txBody>
-      </p:sp>
-      <p:pic>
-        <p:nvPicPr>
-          <p:cNvPr id="153" name="Image 42" descr="preencoded.png">    </p:cNvPr>
-          <p:cNvPicPr>
-            <a:picLocks noChangeAspect="1"/>
-          </p:cNvPicPr>
-          <p:nvPr/>
-        </p:nvPicPr>
-        <p:blipFill>
-          <a:blip r:embed="rId43"/>
-          <a:stretch>
-            <a:fillRect/>
-          </a:stretch>
-        </p:blipFill>
-        <p:spPr>
-          <a:xfrm>
-            <a:off x="6370168" y="5486400"/>
-            <a:ext cx="182880" cy="182880"/>
-          </a:xfrm>
-          <a:prstGeom prst="rect">
-            <a:avLst/>
-          </a:prstGeom>
-        </p:spPr>
-      </p:pic>
-      <p:sp>
-        <p:nvSpPr>
-          <p:cNvPr id="154" name="Text 109"/>
-          <p:cNvSpPr txBox="1"/>
-          <p:nvPr/>
-        </p:nvSpPr>
-        <p:spPr>
-          <a:xfrm>
-            <a:off x="6644488" y="5486400"/>
-            <a:ext cx="5090008" cy="182880"/>
-          </a:xfrm>
-          <a:prstGeom prst="rect">
-            <a:avLst/>
-          </a:prstGeom>
-          <a:noFill/>
-          <a:ln/>
-        </p:spPr>
-        <p:txBody>
-          <a:bodyPr wrap="square" lIns="0" tIns="0" rIns="0" bIns="0" rtlCol="0" anchor="ctr"/>
-          <a:lstStyle/>
-          <a:p>
-            <a:pPr algn="l" indent="0" marL="0">
-              <a:lnSpc>
-                <a:spcPct val="95000"/>
-              </a:lnSpc>
-              <a:buNone/>
-            </a:pPr>
-            <a:r>
-              <a:rPr lang="en-US" sz="1000" dirty="0">
-                <a:solidFill>
-                  <a:srgbClr val="1F2937"/>
-                </a:solidFill>
-                <a:latin typeface="Bahnschrift SemiCondensed" pitchFamily="34" charset="0"/>
-                <a:ea typeface="Bahnschrift SemiCondensed" pitchFamily="34" charset="-122"/>
-                <a:cs typeface="Bahnschrift SemiCondensed" pitchFamily="34" charset="-120"/>
-              </a:rPr>
-              <a:t>DNN / APN недоступен</a:t>
-            </a:r>
-            <a:endParaRPr lang="en-US" sz="1000" dirty="0"/>
-          </a:p>
-        </p:txBody>
-      </p:sp>
-      <p:pic>
-        <p:nvPicPr>
-          <p:cNvPr id="155" name="Image 43" descr="preencoded.png">    </p:cNvPr>
+          <p:cNvPr id="144" name="Image 43" descr="preencoded.png">    </p:cNvPr>
           <p:cNvPicPr>
             <a:picLocks noChangeAspect="1"/>
           </p:cNvPicPr>
@@ -10688,7 +10341,7 @@
         </p:blipFill>
         <p:spPr>
           <a:xfrm>
-            <a:off x="6370168" y="5669280"/>
+            <a:off x="822960" y="5303520"/>
             <a:ext cx="182880" cy="182880"/>
           </a:xfrm>
           <a:prstGeom prst="rect">
@@ -10698,14 +10351,14 @@
       </p:pic>
       <p:sp>
         <p:nvSpPr>
-          <p:cNvPr id="156" name="Text 110"/>
-          <p:cNvSpPr txBox="1"/>
-          <p:nvPr/>
-        </p:nvSpPr>
-        <p:spPr>
-          <a:xfrm>
-            <a:off x="6644488" y="5669280"/>
-            <a:ext cx="5090008" cy="182880"/>
+          <p:cNvPr id="145" name="Text 99"/>
+          <p:cNvSpPr txBox="1"/>
+          <p:nvPr/>
+        </p:nvSpPr>
+        <p:spPr>
+          <a:xfrm>
+            <a:off x="1097280" y="5303520"/>
+            <a:ext cx="4846320" cy="182880"/>
           </a:xfrm>
           <a:prstGeom prst="rect">
             <a:avLst/>
@@ -10732,7 +10385,7 @@
                 <a:ea typeface="Bahnschrift SemiCondensed" pitchFamily="34" charset="-122"/>
                 <a:cs typeface="Bahnschrift SemiCondensed" pitchFamily="34" charset="-120"/>
               </a:rPr>
-              <a:t>сервис запрещён профилем подписки</a:t>
+              <a:t>UE не регистрируется</a:t>
             </a:r>
             <a:endParaRPr lang="en-US" sz="1000" dirty="0"/>
           </a:p>
@@ -10740,7 +10393,7 @@
       </p:sp>
       <p:pic>
         <p:nvPicPr>
-          <p:cNvPr id="157" name="Image 44" descr="preencoded.png">    </p:cNvPr>
+          <p:cNvPr id="146" name="Image 44" descr="preencoded.png">    </p:cNvPr>
           <p:cNvPicPr>
             <a:picLocks noChangeAspect="1"/>
           </p:cNvPicPr>
@@ -10754,7 +10407,7 @@
         </p:blipFill>
         <p:spPr>
           <a:xfrm>
-            <a:off x="6370168" y="5852160"/>
+            <a:off x="822960" y="5486400"/>
             <a:ext cx="182880" cy="182880"/>
           </a:xfrm>
           <a:prstGeom prst="rect">
@@ -10764,14 +10417,14 @@
       </p:pic>
       <p:sp>
         <p:nvSpPr>
-          <p:cNvPr id="158" name="Text 111"/>
-          <p:cNvSpPr txBox="1"/>
-          <p:nvPr/>
-        </p:nvSpPr>
-        <p:spPr>
-          <a:xfrm>
-            <a:off x="6644488" y="5852160"/>
-            <a:ext cx="5090008" cy="182880"/>
+          <p:cNvPr id="147" name="Text 100"/>
+          <p:cNvSpPr txBox="1"/>
+          <p:nvPr/>
+        </p:nvSpPr>
+        <p:spPr>
+          <a:xfrm>
+            <a:off x="1097280" y="5486400"/>
+            <a:ext cx="4846320" cy="182880"/>
           </a:xfrm>
           <a:prstGeom prst="rect">
             <a:avLst/>
@@ -10798,37 +10451,15 @@
                 <a:ea typeface="Bahnschrift SemiCondensed" pitchFamily="34" charset="-122"/>
                 <a:cs typeface="Bahnschrift SemiCondensed" pitchFamily="34" charset="-120"/>
               </a:rPr>
-              <a:t>ошибка выглядит как Core issue, но причина в SIM / USIM / eSIM profile</a:t>
+              <a:t>аутентификация не проходит</a:t>
             </a:r>
             <a:endParaRPr lang="en-US" sz="1000" dirty="0"/>
           </a:p>
         </p:txBody>
-      </p:sp>
-      <p:sp>
-        <p:nvSpPr>
-          <p:cNvPr id="159" name="Shape 112"/>
-          <p:cNvSpPr/>
-          <p:nvPr/>
-        </p:nvSpPr>
-        <p:spPr>
-          <a:xfrm>
-            <a:off x="274320" y="6163056"/>
-            <a:ext cx="11643055" cy="548640"/>
-          </a:xfrm>
-          <a:prstGeom prst="roundRect">
-            <a:avLst>
-              <a:gd name="adj" fmla="val 16667"/>
-            </a:avLst>
-          </a:prstGeom>
-          <a:solidFill>
-            <a:srgbClr val="534EE6"/>
-          </a:solidFill>
-          <a:ln/>
-        </p:spPr>
       </p:sp>
       <p:pic>
         <p:nvPicPr>
-          <p:cNvPr id="160" name="Image 45" descr="preencoded.png">    </p:cNvPr>
+          <p:cNvPr id="148" name="Image 45" descr="preencoded.png">    </p:cNvPr>
           <p:cNvPicPr>
             <a:picLocks noChangeAspect="1"/>
           </p:cNvPicPr>
@@ -10842,6 +10473,447 @@
         </p:blipFill>
         <p:spPr>
           <a:xfrm>
+            <a:off x="822960" y="5669280"/>
+            <a:ext cx="182880" cy="182880"/>
+          </a:xfrm>
+          <a:prstGeom prst="rect">
+            <a:avLst/>
+          </a:prstGeom>
+        </p:spPr>
+      </p:pic>
+      <p:sp>
+        <p:nvSpPr>
+          <p:cNvPr id="149" name="Text 101"/>
+          <p:cNvSpPr txBox="1"/>
+          <p:nvPr/>
+        </p:nvSpPr>
+        <p:spPr>
+          <a:xfrm>
+            <a:off x="1097280" y="5669280"/>
+            <a:ext cx="4846320" cy="182880"/>
+          </a:xfrm>
+          <a:prstGeom prst="rect">
+            <a:avLst/>
+          </a:prstGeom>
+          <a:noFill/>
+          <a:ln/>
+        </p:spPr>
+        <p:txBody>
+          <a:bodyPr wrap="square" lIns="0" tIns="0" rIns="0" bIns="0" rtlCol="0" anchor="ctr"/>
+          <a:lstStyle/>
+          <a:p>
+            <a:pPr algn="l" indent="0" marL="0">
+              <a:lnSpc>
+                <a:spcPct val="95000"/>
+              </a:lnSpc>
+              <a:buNone/>
+            </a:pPr>
+            <a:r>
+              <a:rPr lang="en-US" sz="1000" dirty="0">
+                <a:solidFill>
+                  <a:srgbClr val="1F2937"/>
+                </a:solidFill>
+                <a:latin typeface="Bahnschrift SemiCondensed" pitchFamily="34" charset="0"/>
+                <a:ea typeface="Bahnschrift SemiCondensed" pitchFamily="34" charset="-122"/>
+                <a:cs typeface="Bahnschrift SemiCondensed" pitchFamily="34" charset="-120"/>
+              </a:rPr>
+              <a:t>PDU Session отклоняется</a:t>
+            </a:r>
+            <a:endParaRPr lang="en-US" sz="1000" dirty="0"/>
+          </a:p>
+        </p:txBody>
+      </p:sp>
+      <p:pic>
+        <p:nvPicPr>
+          <p:cNvPr id="150" name="Image 46" descr="preencoded.png">    </p:cNvPr>
+          <p:cNvPicPr>
+            <a:picLocks noChangeAspect="1"/>
+          </p:cNvPicPr>
+          <p:nvPr/>
+        </p:nvPicPr>
+        <p:blipFill>
+          <a:blip r:embed="rId47"/>
+          <a:stretch>
+            <a:fillRect/>
+          </a:stretch>
+        </p:blipFill>
+        <p:spPr>
+          <a:xfrm>
+            <a:off x="822960" y="5852160"/>
+            <a:ext cx="182880" cy="182880"/>
+          </a:xfrm>
+          <a:prstGeom prst="rect">
+            <a:avLst/>
+          </a:prstGeom>
+        </p:spPr>
+      </p:pic>
+      <p:sp>
+        <p:nvSpPr>
+          <p:cNvPr id="151" name="Text 102"/>
+          <p:cNvSpPr txBox="1"/>
+          <p:nvPr/>
+        </p:nvSpPr>
+        <p:spPr>
+          <a:xfrm>
+            <a:off x="1097280" y="5852160"/>
+            <a:ext cx="4846320" cy="182880"/>
+          </a:xfrm>
+          <a:prstGeom prst="rect">
+            <a:avLst/>
+          </a:prstGeom>
+          <a:noFill/>
+          <a:ln/>
+        </p:spPr>
+        <p:txBody>
+          <a:bodyPr wrap="square" lIns="0" tIns="0" rIns="0" bIns="0" rtlCol="0" anchor="ctr"/>
+          <a:lstStyle/>
+          <a:p>
+            <a:pPr algn="l" indent="0" marL="0">
+              <a:lnSpc>
+                <a:spcPct val="95000"/>
+              </a:lnSpc>
+              <a:buNone/>
+            </a:pPr>
+            <a:r>
+              <a:rPr lang="en-US" sz="1000" dirty="0">
+                <a:solidFill>
+                  <a:srgbClr val="1F2937"/>
+                </a:solidFill>
+                <a:latin typeface="Bahnschrift SemiCondensed" pitchFamily="34" charset="0"/>
+                <a:ea typeface="Bahnschrift SemiCondensed" pitchFamily="34" charset="-122"/>
+                <a:cs typeface="Bahnschrift SemiCondensed" pitchFamily="34" charset="-120"/>
+              </a:rPr>
+              <a:t>роуминг не работает</a:t>
+            </a:r>
+            <a:endParaRPr lang="en-US" sz="1000" dirty="0"/>
+          </a:p>
+        </p:txBody>
+      </p:sp>
+      <p:sp>
+        <p:nvSpPr>
+          <p:cNvPr id="152" name="Shape 103"/>
+          <p:cNvSpPr/>
+          <p:nvPr/>
+        </p:nvSpPr>
+        <p:spPr>
+          <a:xfrm>
+            <a:off x="6095848" y="5340096"/>
+            <a:ext cx="0" cy="621792"/>
+          </a:xfrm>
+          <a:prstGeom prst="line">
+            <a:avLst/>
+          </a:prstGeom>
+          <a:noFill/>
+          <a:ln w="9525">
+            <a:solidFill>
+              <a:srgbClr val="7F7BEC"/>
+            </a:solidFill>
+            <a:prstDash val="dash"/>
+          </a:ln>
+        </p:spPr>
+      </p:sp>
+      <p:pic>
+        <p:nvPicPr>
+          <p:cNvPr id="153" name="Image 47" descr="preencoded.png">    </p:cNvPr>
+          <p:cNvPicPr>
+            <a:picLocks noChangeAspect="1"/>
+          </p:cNvPicPr>
+          <p:nvPr/>
+        </p:nvPicPr>
+        <p:blipFill>
+          <a:blip r:embed="rId48"/>
+          <a:stretch>
+            <a:fillRect/>
+          </a:stretch>
+        </p:blipFill>
+        <p:spPr>
+          <a:xfrm>
+            <a:off x="6370168" y="5303520"/>
+            <a:ext cx="182880" cy="182880"/>
+          </a:xfrm>
+          <a:prstGeom prst="rect">
+            <a:avLst/>
+          </a:prstGeom>
+        </p:spPr>
+      </p:pic>
+      <p:sp>
+        <p:nvSpPr>
+          <p:cNvPr id="154" name="Text 104"/>
+          <p:cNvSpPr txBox="1"/>
+          <p:nvPr/>
+        </p:nvSpPr>
+        <p:spPr>
+          <a:xfrm>
+            <a:off x="6644488" y="5303520"/>
+            <a:ext cx="5090008" cy="182880"/>
+          </a:xfrm>
+          <a:prstGeom prst="rect">
+            <a:avLst/>
+          </a:prstGeom>
+          <a:noFill/>
+          <a:ln/>
+        </p:spPr>
+        <p:txBody>
+          <a:bodyPr wrap="square" lIns="0" tIns="0" rIns="0" bIns="0" rtlCol="0" anchor="ctr"/>
+          <a:lstStyle/>
+          <a:p>
+            <a:pPr algn="l" indent="0" marL="0">
+              <a:lnSpc>
+                <a:spcPct val="95000"/>
+              </a:lnSpc>
+              <a:buNone/>
+            </a:pPr>
+            <a:r>
+              <a:rPr lang="en-US" sz="1000" dirty="0">
+                <a:solidFill>
+                  <a:srgbClr val="1F2937"/>
+                </a:solidFill>
+                <a:latin typeface="Bahnschrift SemiCondensed" pitchFamily="34" charset="0"/>
+                <a:ea typeface="Bahnschrift SemiCondensed" pitchFamily="34" charset="-122"/>
+                <a:cs typeface="Bahnschrift SemiCondensed" pitchFamily="34" charset="-120"/>
+              </a:rPr>
+              <a:t>IMS / VoLTE / VoNR не регистрируется</a:t>
+            </a:r>
+            <a:endParaRPr lang="en-US" sz="1000" dirty="0"/>
+          </a:p>
+        </p:txBody>
+      </p:sp>
+      <p:pic>
+        <p:nvPicPr>
+          <p:cNvPr id="155" name="Image 48" descr="preencoded.png">    </p:cNvPr>
+          <p:cNvPicPr>
+            <a:picLocks noChangeAspect="1"/>
+          </p:cNvPicPr>
+          <p:nvPr/>
+        </p:nvPicPr>
+        <p:blipFill>
+          <a:blip r:embed="rId49"/>
+          <a:stretch>
+            <a:fillRect/>
+          </a:stretch>
+        </p:blipFill>
+        <p:spPr>
+          <a:xfrm>
+            <a:off x="6370168" y="5486400"/>
+            <a:ext cx="182880" cy="182880"/>
+          </a:xfrm>
+          <a:prstGeom prst="rect">
+            <a:avLst/>
+          </a:prstGeom>
+        </p:spPr>
+      </p:pic>
+      <p:sp>
+        <p:nvSpPr>
+          <p:cNvPr id="156" name="Text 105"/>
+          <p:cNvSpPr txBox="1"/>
+          <p:nvPr/>
+        </p:nvSpPr>
+        <p:spPr>
+          <a:xfrm>
+            <a:off x="6644488" y="5486400"/>
+            <a:ext cx="5090008" cy="182880"/>
+          </a:xfrm>
+          <a:prstGeom prst="rect">
+            <a:avLst/>
+          </a:prstGeom>
+          <a:noFill/>
+          <a:ln/>
+        </p:spPr>
+        <p:txBody>
+          <a:bodyPr wrap="square" lIns="0" tIns="0" rIns="0" bIns="0" rtlCol="0" anchor="ctr"/>
+          <a:lstStyle/>
+          <a:p>
+            <a:pPr algn="l" indent="0" marL="0">
+              <a:lnSpc>
+                <a:spcPct val="95000"/>
+              </a:lnSpc>
+              <a:buNone/>
+            </a:pPr>
+            <a:r>
+              <a:rPr lang="en-US" sz="1000" dirty="0">
+                <a:solidFill>
+                  <a:srgbClr val="1F2937"/>
+                </a:solidFill>
+                <a:latin typeface="Bahnschrift SemiCondensed" pitchFamily="34" charset="0"/>
+                <a:ea typeface="Bahnschrift SemiCondensed" pitchFamily="34" charset="-122"/>
+                <a:cs typeface="Bahnschrift SemiCondensed" pitchFamily="34" charset="-120"/>
+              </a:rPr>
+              <a:t>DNN / APN недоступен</a:t>
+            </a:r>
+            <a:endParaRPr lang="en-US" sz="1000" dirty="0"/>
+          </a:p>
+        </p:txBody>
+      </p:sp>
+      <p:pic>
+        <p:nvPicPr>
+          <p:cNvPr id="157" name="Image 49" descr="preencoded.png">    </p:cNvPr>
+          <p:cNvPicPr>
+            <a:picLocks noChangeAspect="1"/>
+          </p:cNvPicPr>
+          <p:nvPr/>
+        </p:nvPicPr>
+        <p:blipFill>
+          <a:blip r:embed="rId50"/>
+          <a:stretch>
+            <a:fillRect/>
+          </a:stretch>
+        </p:blipFill>
+        <p:spPr>
+          <a:xfrm>
+            <a:off x="6370168" y="5669280"/>
+            <a:ext cx="182880" cy="182880"/>
+          </a:xfrm>
+          <a:prstGeom prst="rect">
+            <a:avLst/>
+          </a:prstGeom>
+        </p:spPr>
+      </p:pic>
+      <p:sp>
+        <p:nvSpPr>
+          <p:cNvPr id="158" name="Text 106"/>
+          <p:cNvSpPr txBox="1"/>
+          <p:nvPr/>
+        </p:nvSpPr>
+        <p:spPr>
+          <a:xfrm>
+            <a:off x="6644488" y="5669280"/>
+            <a:ext cx="5090008" cy="182880"/>
+          </a:xfrm>
+          <a:prstGeom prst="rect">
+            <a:avLst/>
+          </a:prstGeom>
+          <a:noFill/>
+          <a:ln/>
+        </p:spPr>
+        <p:txBody>
+          <a:bodyPr wrap="square" lIns="0" tIns="0" rIns="0" bIns="0" rtlCol="0" anchor="ctr"/>
+          <a:lstStyle/>
+          <a:p>
+            <a:pPr algn="l" indent="0" marL="0">
+              <a:lnSpc>
+                <a:spcPct val="95000"/>
+              </a:lnSpc>
+              <a:buNone/>
+            </a:pPr>
+            <a:r>
+              <a:rPr lang="en-US" sz="1000" dirty="0">
+                <a:solidFill>
+                  <a:srgbClr val="1F2937"/>
+                </a:solidFill>
+                <a:latin typeface="Bahnschrift SemiCondensed" pitchFamily="34" charset="0"/>
+                <a:ea typeface="Bahnschrift SemiCondensed" pitchFamily="34" charset="-122"/>
+                <a:cs typeface="Bahnschrift SemiCondensed" pitchFamily="34" charset="-120"/>
+              </a:rPr>
+              <a:t>сервис запрещён профилем подписки</a:t>
+            </a:r>
+            <a:endParaRPr lang="en-US" sz="1000" dirty="0"/>
+          </a:p>
+        </p:txBody>
+      </p:sp>
+      <p:pic>
+        <p:nvPicPr>
+          <p:cNvPr id="159" name="Image 50" descr="preencoded.png">    </p:cNvPr>
+          <p:cNvPicPr>
+            <a:picLocks noChangeAspect="1"/>
+          </p:cNvPicPr>
+          <p:nvPr/>
+        </p:nvPicPr>
+        <p:blipFill>
+          <a:blip r:embed="rId51"/>
+          <a:stretch>
+            <a:fillRect/>
+          </a:stretch>
+        </p:blipFill>
+        <p:spPr>
+          <a:xfrm>
+            <a:off x="6370168" y="5852160"/>
+            <a:ext cx="182880" cy="182880"/>
+          </a:xfrm>
+          <a:prstGeom prst="rect">
+            <a:avLst/>
+          </a:prstGeom>
+        </p:spPr>
+      </p:pic>
+      <p:sp>
+        <p:nvSpPr>
+          <p:cNvPr id="160" name="Text 107"/>
+          <p:cNvSpPr txBox="1"/>
+          <p:nvPr/>
+        </p:nvSpPr>
+        <p:spPr>
+          <a:xfrm>
+            <a:off x="6644488" y="5852160"/>
+            <a:ext cx="5090008" cy="182880"/>
+          </a:xfrm>
+          <a:prstGeom prst="rect">
+            <a:avLst/>
+          </a:prstGeom>
+          <a:noFill/>
+          <a:ln/>
+        </p:spPr>
+        <p:txBody>
+          <a:bodyPr wrap="square" lIns="0" tIns="0" rIns="0" bIns="0" rtlCol="0" anchor="ctr"/>
+          <a:lstStyle/>
+          <a:p>
+            <a:pPr algn="l" indent="0" marL="0">
+              <a:lnSpc>
+                <a:spcPct val="95000"/>
+              </a:lnSpc>
+              <a:buNone/>
+            </a:pPr>
+            <a:r>
+              <a:rPr lang="en-US" sz="1000" dirty="0">
+                <a:solidFill>
+                  <a:srgbClr val="1F2937"/>
+                </a:solidFill>
+                <a:latin typeface="Bahnschrift SemiCondensed" pitchFamily="34" charset="0"/>
+                <a:ea typeface="Bahnschrift SemiCondensed" pitchFamily="34" charset="-122"/>
+                <a:cs typeface="Bahnschrift SemiCondensed" pitchFamily="34" charset="-120"/>
+              </a:rPr>
+              <a:t>ошибка выглядит как Core issue, но причина в SIM / USIM / eSIM profile</a:t>
+            </a:r>
+            <a:endParaRPr lang="en-US" sz="1000" dirty="0"/>
+          </a:p>
+        </p:txBody>
+      </p:sp>
+      <p:sp>
+        <p:nvSpPr>
+          <p:cNvPr id="161" name="Shape 108"/>
+          <p:cNvSpPr/>
+          <p:nvPr/>
+        </p:nvSpPr>
+        <p:spPr>
+          <a:xfrm>
+            <a:off x="274320" y="6163056"/>
+            <a:ext cx="11643055" cy="548640"/>
+          </a:xfrm>
+          <a:prstGeom prst="roundRect">
+            <a:avLst>
+              <a:gd name="adj" fmla="val 16667"/>
+            </a:avLst>
+          </a:prstGeom>
+          <a:solidFill>
+            <a:srgbClr val="534EE6"/>
+          </a:solidFill>
+          <a:ln/>
+        </p:spPr>
+      </p:sp>
+      <p:pic>
+        <p:nvPicPr>
+          <p:cNvPr id="162" name="Image 51" descr="preencoded.png">    </p:cNvPr>
+          <p:cNvPicPr>
+            <a:picLocks noChangeAspect="1"/>
+          </p:cNvPicPr>
+          <p:nvPr/>
+        </p:nvPicPr>
+        <p:blipFill>
+          <a:blip r:embed="rId52"/>
+          <a:stretch>
+            <a:fillRect/>
+          </a:stretch>
+        </p:blipFill>
+        <p:spPr>
+          <a:xfrm>
             <a:off x="548640" y="6254496"/>
             <a:ext cx="365760" cy="365760"/>
           </a:xfrm>
@@ -10852,7 +10924,7 @@
       </p:pic>
       <p:sp>
         <p:nvSpPr>
-          <p:cNvPr id="161" name="Text 113"/>
+          <p:cNvPr id="163" name="Text 109"/>
           <p:cNvSpPr txBox="1"/>
           <p:nvPr/>
         </p:nvSpPr>
@@ -11500,16 +11572,40 @@
           </a:p>
         </p:txBody>
       </p:sp>
-      <p:sp>
-        <p:nvSpPr>
-          <p:cNvPr id="20" name="Text 17"/>
-          <p:cNvSpPr txBox="1"/>
-          <p:nvPr/>
-        </p:nvSpPr>
-        <p:spPr>
-          <a:xfrm>
-            <a:off x="1645920" y="1161288"/>
-            <a:ext cx="2311832" cy="219456"/>
+      <p:pic>
+        <p:nvPicPr>
+          <p:cNvPr id="20" name="Image 1" descr="preencoded.png">    </p:cNvPr>
+          <p:cNvPicPr>
+            <a:picLocks noChangeAspect="1"/>
+          </p:cNvPicPr>
+          <p:nvPr/>
+        </p:nvPicPr>
+        <p:blipFill>
+          <a:blip r:embed="rId2"/>
+          <a:stretch>
+            <a:fillRect/>
+          </a:stretch>
+        </p:blipFill>
+        <p:spPr>
+          <a:xfrm>
+            <a:off x="1645920" y="1193292"/>
+            <a:ext cx="155448" cy="155448"/>
+          </a:xfrm>
+          <a:prstGeom prst="rect">
+            <a:avLst/>
+          </a:prstGeom>
+        </p:spPr>
+      </p:pic>
+      <p:sp>
+        <p:nvSpPr>
+          <p:cNvPr id="21" name="Text 17"/>
+          <p:cNvSpPr txBox="1"/>
+          <p:nvPr/>
+        </p:nvSpPr>
+        <p:spPr>
+          <a:xfrm>
+            <a:off x="1865376" y="1161288"/>
+            <a:ext cx="2092376" cy="219456"/>
           </a:xfrm>
           <a:prstGeom prst="rect">
             <a:avLst/>
@@ -11544,7 +11640,7 @@
       </p:sp>
       <p:sp>
         <p:nvSpPr>
-          <p:cNvPr id="21" name="Shape 18"/>
+          <p:cNvPr id="22" name="Shape 18"/>
           <p:cNvSpPr/>
           <p:nvPr/>
         </p:nvSpPr>
@@ -11564,7 +11660,7 @@
       </p:sp>
       <p:sp>
         <p:nvSpPr>
-          <p:cNvPr id="22" name="Text 19"/>
+          <p:cNvPr id="23" name="Text 19"/>
           <p:cNvSpPr txBox="1"/>
           <p:nvPr/>
         </p:nvSpPr>
@@ -11606,7 +11702,7 @@
       </p:sp>
       <p:sp>
         <p:nvSpPr>
-          <p:cNvPr id="23" name="Shape 20"/>
+          <p:cNvPr id="24" name="Shape 20"/>
           <p:cNvSpPr/>
           <p:nvPr/>
         </p:nvSpPr>
@@ -11626,7 +11722,7 @@
       </p:sp>
       <p:sp>
         <p:nvSpPr>
-          <p:cNvPr id="24" name="Text 21"/>
+          <p:cNvPr id="25" name="Text 21"/>
           <p:cNvSpPr txBox="1"/>
           <p:nvPr/>
         </p:nvSpPr>
@@ -11668,7 +11764,7 @@
       </p:sp>
       <p:sp>
         <p:nvSpPr>
-          <p:cNvPr id="25" name="Shape 22"/>
+          <p:cNvPr id="26" name="Shape 22"/>
           <p:cNvSpPr/>
           <p:nvPr/>
         </p:nvSpPr>
@@ -11688,7 +11784,7 @@
       </p:sp>
       <p:sp>
         <p:nvSpPr>
-          <p:cNvPr id="26" name="Text 23"/>
+          <p:cNvPr id="27" name="Text 23"/>
           <p:cNvSpPr txBox="1"/>
           <p:nvPr/>
         </p:nvSpPr>
@@ -11730,7 +11826,7 @@
       </p:sp>
       <p:sp>
         <p:nvSpPr>
-          <p:cNvPr id="27" name="Shape 24"/>
+          <p:cNvPr id="28" name="Shape 24"/>
           <p:cNvSpPr/>
           <p:nvPr/>
         </p:nvSpPr>
@@ -11750,7 +11846,7 @@
       </p:sp>
       <p:sp>
         <p:nvSpPr>
-          <p:cNvPr id="28" name="Text 25"/>
+          <p:cNvPr id="29" name="Text 25"/>
           <p:cNvSpPr txBox="1"/>
           <p:nvPr/>
         </p:nvSpPr>
@@ -11790,16 +11886,40 @@
           </a:p>
         </p:txBody>
       </p:sp>
-      <p:sp>
-        <p:nvSpPr>
-          <p:cNvPr id="29" name="Text 26"/>
-          <p:cNvSpPr txBox="1"/>
-          <p:nvPr/>
-        </p:nvSpPr>
-        <p:spPr>
-          <a:xfrm>
-            <a:off x="1645920" y="2377623"/>
-            <a:ext cx="2311832" cy="219456"/>
+      <p:pic>
+        <p:nvPicPr>
+          <p:cNvPr id="30" name="Image 2" descr="preencoded.png">    </p:cNvPr>
+          <p:cNvPicPr>
+            <a:picLocks noChangeAspect="1"/>
+          </p:cNvPicPr>
+          <p:nvPr/>
+        </p:nvPicPr>
+        <p:blipFill>
+          <a:blip r:embed="rId3"/>
+          <a:stretch>
+            <a:fillRect/>
+          </a:stretch>
+        </p:blipFill>
+        <p:spPr>
+          <a:xfrm>
+            <a:off x="1645920" y="2409627"/>
+            <a:ext cx="155448" cy="155448"/>
+          </a:xfrm>
+          <a:prstGeom prst="rect">
+            <a:avLst/>
+          </a:prstGeom>
+        </p:spPr>
+      </p:pic>
+      <p:sp>
+        <p:nvSpPr>
+          <p:cNvPr id="31" name="Text 26"/>
+          <p:cNvSpPr txBox="1"/>
+          <p:nvPr/>
+        </p:nvSpPr>
+        <p:spPr>
+          <a:xfrm>
+            <a:off x="1865376" y="2377623"/>
+            <a:ext cx="2092376" cy="219456"/>
           </a:xfrm>
           <a:prstGeom prst="rect">
             <a:avLst/>
@@ -11834,7 +11954,7 @@
       </p:sp>
       <p:sp>
         <p:nvSpPr>
-          <p:cNvPr id="30" name="Shape 27"/>
+          <p:cNvPr id="32" name="Shape 27"/>
           <p:cNvSpPr/>
           <p:nvPr/>
         </p:nvSpPr>
@@ -11854,7 +11974,7 @@
       </p:sp>
       <p:sp>
         <p:nvSpPr>
-          <p:cNvPr id="31" name="Text 28"/>
+          <p:cNvPr id="33" name="Text 28"/>
           <p:cNvSpPr txBox="1"/>
           <p:nvPr/>
         </p:nvSpPr>
@@ -11896,7 +12016,7 @@
       </p:sp>
       <p:sp>
         <p:nvSpPr>
-          <p:cNvPr id="32" name="Shape 29"/>
+          <p:cNvPr id="34" name="Shape 29"/>
           <p:cNvSpPr/>
           <p:nvPr/>
         </p:nvSpPr>
@@ -11916,7 +12036,7 @@
       </p:sp>
       <p:sp>
         <p:nvSpPr>
-          <p:cNvPr id="33" name="Text 30"/>
+          <p:cNvPr id="35" name="Text 30"/>
           <p:cNvSpPr txBox="1"/>
           <p:nvPr/>
         </p:nvSpPr>
@@ -11956,16 +12076,40 @@
           </a:p>
         </p:txBody>
       </p:sp>
-      <p:sp>
-        <p:nvSpPr>
-          <p:cNvPr id="34" name="Text 31"/>
-          <p:cNvSpPr txBox="1"/>
-          <p:nvPr/>
-        </p:nvSpPr>
-        <p:spPr>
-          <a:xfrm>
-            <a:off x="1645920" y="3246486"/>
-            <a:ext cx="2311832" cy="219456"/>
+      <p:pic>
+        <p:nvPicPr>
+          <p:cNvPr id="36" name="Image 3" descr="preencoded.png">    </p:cNvPr>
+          <p:cNvPicPr>
+            <a:picLocks noChangeAspect="1"/>
+          </p:cNvPicPr>
+          <p:nvPr/>
+        </p:nvPicPr>
+        <p:blipFill>
+          <a:blip r:embed="rId4"/>
+          <a:stretch>
+            <a:fillRect/>
+          </a:stretch>
+        </p:blipFill>
+        <p:spPr>
+          <a:xfrm>
+            <a:off x="1645920" y="3278490"/>
+            <a:ext cx="155448" cy="155448"/>
+          </a:xfrm>
+          <a:prstGeom prst="rect">
+            <a:avLst/>
+          </a:prstGeom>
+        </p:spPr>
+      </p:pic>
+      <p:sp>
+        <p:nvSpPr>
+          <p:cNvPr id="37" name="Text 31"/>
+          <p:cNvSpPr txBox="1"/>
+          <p:nvPr/>
+        </p:nvSpPr>
+        <p:spPr>
+          <a:xfrm>
+            <a:off x="1865376" y="3246486"/>
+            <a:ext cx="2092376" cy="219456"/>
           </a:xfrm>
           <a:prstGeom prst="rect">
             <a:avLst/>
@@ -12000,7 +12144,7 @@
       </p:sp>
       <p:sp>
         <p:nvSpPr>
-          <p:cNvPr id="35" name="Shape 32"/>
+          <p:cNvPr id="38" name="Shape 32"/>
           <p:cNvSpPr/>
           <p:nvPr/>
         </p:nvSpPr>
@@ -12020,7 +12164,7 @@
       </p:sp>
       <p:sp>
         <p:nvSpPr>
-          <p:cNvPr id="36" name="Text 33"/>
+          <p:cNvPr id="39" name="Text 33"/>
           <p:cNvSpPr txBox="1"/>
           <p:nvPr/>
         </p:nvSpPr>
@@ -12062,7 +12206,7 @@
       </p:sp>
       <p:sp>
         <p:nvSpPr>
-          <p:cNvPr id="37" name="Shape 34"/>
+          <p:cNvPr id="40" name="Shape 34"/>
           <p:cNvSpPr/>
           <p:nvPr/>
         </p:nvSpPr>
@@ -12082,7 +12226,7 @@
       </p:sp>
       <p:sp>
         <p:nvSpPr>
-          <p:cNvPr id="38" name="Text 35"/>
+          <p:cNvPr id="41" name="Text 35"/>
           <p:cNvSpPr txBox="1"/>
           <p:nvPr/>
         </p:nvSpPr>
@@ -12124,7 +12268,7 @@
       </p:sp>
       <p:sp>
         <p:nvSpPr>
-          <p:cNvPr id="39" name="Shape 36"/>
+          <p:cNvPr id="42" name="Shape 36"/>
           <p:cNvSpPr/>
           <p:nvPr/>
         </p:nvSpPr>
@@ -12144,7 +12288,7 @@
       </p:sp>
       <p:sp>
         <p:nvSpPr>
-          <p:cNvPr id="40" name="Text 37"/>
+          <p:cNvPr id="43" name="Text 37"/>
           <p:cNvSpPr txBox="1"/>
           <p:nvPr/>
         </p:nvSpPr>
@@ -12186,7 +12330,7 @@
       </p:sp>
       <p:sp>
         <p:nvSpPr>
-          <p:cNvPr id="41" name="Shape 38"/>
+          <p:cNvPr id="44" name="Shape 38"/>
           <p:cNvSpPr/>
           <p:nvPr/>
         </p:nvSpPr>
@@ -12206,7 +12350,7 @@
       </p:sp>
       <p:sp>
         <p:nvSpPr>
-          <p:cNvPr id="42" name="Text 39"/>
+          <p:cNvPr id="45" name="Text 39"/>
           <p:cNvSpPr txBox="1"/>
           <p:nvPr/>
         </p:nvSpPr>
@@ -12248,7 +12392,7 @@
       </p:sp>
       <p:sp>
         <p:nvSpPr>
-          <p:cNvPr id="43" name="Shape 40"/>
+          <p:cNvPr id="46" name="Shape 40"/>
           <p:cNvSpPr/>
           <p:nvPr/>
         </p:nvSpPr>
@@ -12268,7 +12412,7 @@
       </p:sp>
       <p:sp>
         <p:nvSpPr>
-          <p:cNvPr id="44" name="Text 41"/>
+          <p:cNvPr id="47" name="Text 41"/>
           <p:cNvSpPr txBox="1"/>
           <p:nvPr/>
         </p:nvSpPr>
@@ -12310,7 +12454,7 @@
       </p:sp>
       <p:sp>
         <p:nvSpPr>
-          <p:cNvPr id="45" name="Shape 42"/>
+          <p:cNvPr id="48" name="Shape 42"/>
           <p:cNvSpPr/>
           <p:nvPr/>
         </p:nvSpPr>
@@ -12332,7 +12476,7 @@
       </p:sp>
       <p:sp>
         <p:nvSpPr>
-          <p:cNvPr id="46" name="Text 43"/>
+          <p:cNvPr id="49" name="Text 43"/>
           <p:cNvSpPr txBox="1"/>
           <p:nvPr/>
         </p:nvSpPr>
@@ -12374,7 +12518,7 @@
       </p:sp>
       <p:sp>
         <p:nvSpPr>
-          <p:cNvPr id="47" name="Shape 44"/>
+          <p:cNvPr id="50" name="Shape 44"/>
           <p:cNvSpPr/>
           <p:nvPr/>
         </p:nvSpPr>
@@ -12399,7 +12543,7 @@
       </p:sp>
       <p:sp>
         <p:nvSpPr>
-          <p:cNvPr id="48" name="Shape 45"/>
+          <p:cNvPr id="51" name="Shape 45"/>
           <p:cNvSpPr/>
           <p:nvPr/>
         </p:nvSpPr>
@@ -12426,7 +12570,7 @@
       </p:sp>
       <p:sp>
         <p:nvSpPr>
-          <p:cNvPr id="49" name="Shape 46"/>
+          <p:cNvPr id="52" name="Shape 46"/>
           <p:cNvSpPr/>
           <p:nvPr/>
         </p:nvSpPr>
@@ -12446,7 +12590,7 @@
       </p:sp>
       <p:sp>
         <p:nvSpPr>
-          <p:cNvPr id="50" name="Text 47"/>
+          <p:cNvPr id="53" name="Text 47"/>
           <p:cNvSpPr txBox="1"/>
           <p:nvPr/>
         </p:nvSpPr>
@@ -12488,7 +12632,7 @@
       </p:sp>
       <p:sp>
         <p:nvSpPr>
-          <p:cNvPr id="51" name="Text 48"/>
+          <p:cNvPr id="54" name="Text 48"/>
           <p:cNvSpPr txBox="1"/>
           <p:nvPr/>
         </p:nvSpPr>
@@ -12528,16 +12672,40 @@
           </a:p>
         </p:txBody>
       </p:sp>
-      <p:sp>
-        <p:nvSpPr>
-          <p:cNvPr id="52" name="Text 49"/>
-          <p:cNvSpPr txBox="1"/>
-          <p:nvPr/>
-        </p:nvSpPr>
-        <p:spPr>
-          <a:xfrm>
-            <a:off x="4268648" y="1161288"/>
-            <a:ext cx="2311832" cy="219456"/>
+      <p:pic>
+        <p:nvPicPr>
+          <p:cNvPr id="55" name="Image 4" descr="preencoded.png">    </p:cNvPr>
+          <p:cNvPicPr>
+            <a:picLocks noChangeAspect="1"/>
+          </p:cNvPicPr>
+          <p:nvPr/>
+        </p:nvPicPr>
+        <p:blipFill>
+          <a:blip r:embed="rId5"/>
+          <a:stretch>
+            <a:fillRect/>
+          </a:stretch>
+        </p:blipFill>
+        <p:spPr>
+          <a:xfrm>
+            <a:off x="4268648" y="1193292"/>
+            <a:ext cx="155448" cy="155448"/>
+          </a:xfrm>
+          <a:prstGeom prst="rect">
+            <a:avLst/>
+          </a:prstGeom>
+        </p:spPr>
+      </p:pic>
+      <p:sp>
+        <p:nvSpPr>
+          <p:cNvPr id="56" name="Text 49"/>
+          <p:cNvSpPr txBox="1"/>
+          <p:nvPr/>
+        </p:nvSpPr>
+        <p:spPr>
+          <a:xfrm>
+            <a:off x="4488104" y="1161288"/>
+            <a:ext cx="2092376" cy="219456"/>
           </a:xfrm>
           <a:prstGeom prst="rect">
             <a:avLst/>
@@ -12572,7 +12740,7 @@
       </p:sp>
       <p:sp>
         <p:nvSpPr>
-          <p:cNvPr id="53" name="Shape 50"/>
+          <p:cNvPr id="57" name="Shape 50"/>
           <p:cNvSpPr/>
           <p:nvPr/>
         </p:nvSpPr>
@@ -12592,7 +12760,7 @@
       </p:sp>
       <p:sp>
         <p:nvSpPr>
-          <p:cNvPr id="54" name="Text 51"/>
+          <p:cNvPr id="58" name="Text 51"/>
           <p:cNvSpPr txBox="1"/>
           <p:nvPr/>
         </p:nvSpPr>
@@ -12634,7 +12802,7 @@
       </p:sp>
       <p:sp>
         <p:nvSpPr>
-          <p:cNvPr id="55" name="Shape 52"/>
+          <p:cNvPr id="59" name="Shape 52"/>
           <p:cNvSpPr/>
           <p:nvPr/>
         </p:nvSpPr>
@@ -12654,7 +12822,7 @@
       </p:sp>
       <p:sp>
         <p:nvSpPr>
-          <p:cNvPr id="56" name="Text 53"/>
+          <p:cNvPr id="60" name="Text 53"/>
           <p:cNvSpPr txBox="1"/>
           <p:nvPr/>
         </p:nvSpPr>
@@ -12696,7 +12864,7 @@
       </p:sp>
       <p:sp>
         <p:nvSpPr>
-          <p:cNvPr id="57" name="Shape 54"/>
+          <p:cNvPr id="61" name="Shape 54"/>
           <p:cNvSpPr/>
           <p:nvPr/>
         </p:nvSpPr>
@@ -12716,7 +12884,7 @@
       </p:sp>
       <p:sp>
         <p:nvSpPr>
-          <p:cNvPr id="58" name="Text 55"/>
+          <p:cNvPr id="62" name="Text 55"/>
           <p:cNvSpPr txBox="1"/>
           <p:nvPr/>
         </p:nvSpPr>
@@ -12756,16 +12924,40 @@
           </a:p>
         </p:txBody>
       </p:sp>
-      <p:sp>
-        <p:nvSpPr>
-          <p:cNvPr id="59" name="Text 56"/>
-          <p:cNvSpPr txBox="1"/>
-          <p:nvPr/>
-        </p:nvSpPr>
-        <p:spPr>
-          <a:xfrm>
-            <a:off x="4268648" y="1929384"/>
-            <a:ext cx="2311832" cy="219456"/>
+      <p:pic>
+        <p:nvPicPr>
+          <p:cNvPr id="63" name="Image 5" descr="preencoded.png">    </p:cNvPr>
+          <p:cNvPicPr>
+            <a:picLocks noChangeAspect="1"/>
+          </p:cNvPicPr>
+          <p:nvPr/>
+        </p:nvPicPr>
+        <p:blipFill>
+          <a:blip r:embed="rId6"/>
+          <a:stretch>
+            <a:fillRect/>
+          </a:stretch>
+        </p:blipFill>
+        <p:spPr>
+          <a:xfrm>
+            <a:off x="4268648" y="1961388"/>
+            <a:ext cx="155448" cy="155448"/>
+          </a:xfrm>
+          <a:prstGeom prst="rect">
+            <a:avLst/>
+          </a:prstGeom>
+        </p:spPr>
+      </p:pic>
+      <p:sp>
+        <p:nvSpPr>
+          <p:cNvPr id="64" name="Text 56"/>
+          <p:cNvSpPr txBox="1"/>
+          <p:nvPr/>
+        </p:nvSpPr>
+        <p:spPr>
+          <a:xfrm>
+            <a:off x="4488104" y="1929384"/>
+            <a:ext cx="2092376" cy="219456"/>
           </a:xfrm>
           <a:prstGeom prst="rect">
             <a:avLst/>
@@ -12800,7 +12992,7 @@
       </p:sp>
       <p:sp>
         <p:nvSpPr>
-          <p:cNvPr id="60" name="Shape 57"/>
+          <p:cNvPr id="65" name="Shape 57"/>
           <p:cNvSpPr/>
           <p:nvPr/>
         </p:nvSpPr>
@@ -12820,7 +13012,7 @@
       </p:sp>
       <p:sp>
         <p:nvSpPr>
-          <p:cNvPr id="61" name="Text 58"/>
+          <p:cNvPr id="66" name="Text 58"/>
           <p:cNvSpPr txBox="1"/>
           <p:nvPr/>
         </p:nvSpPr>
@@ -12862,7 +13054,7 @@
       </p:sp>
       <p:sp>
         <p:nvSpPr>
-          <p:cNvPr id="62" name="Shape 59"/>
+          <p:cNvPr id="67" name="Shape 59"/>
           <p:cNvSpPr/>
           <p:nvPr/>
         </p:nvSpPr>
@@ -12882,7 +13074,7 @@
       </p:sp>
       <p:sp>
         <p:nvSpPr>
-          <p:cNvPr id="63" name="Text 60"/>
+          <p:cNvPr id="68" name="Text 60"/>
           <p:cNvSpPr txBox="1"/>
           <p:nvPr/>
         </p:nvSpPr>
@@ -12922,16 +13114,40 @@
           </a:p>
         </p:txBody>
       </p:sp>
-      <p:sp>
-        <p:nvSpPr>
-          <p:cNvPr id="64" name="Text 61"/>
-          <p:cNvSpPr txBox="1"/>
-          <p:nvPr/>
-        </p:nvSpPr>
-        <p:spPr>
-          <a:xfrm>
-            <a:off x="4268648" y="2798247"/>
-            <a:ext cx="2311832" cy="219456"/>
+      <p:pic>
+        <p:nvPicPr>
+          <p:cNvPr id="69" name="Image 6" descr="preencoded.png">    </p:cNvPr>
+          <p:cNvPicPr>
+            <a:picLocks noChangeAspect="1"/>
+          </p:cNvPicPr>
+          <p:nvPr/>
+        </p:nvPicPr>
+        <p:blipFill>
+          <a:blip r:embed="rId7"/>
+          <a:stretch>
+            <a:fillRect/>
+          </a:stretch>
+        </p:blipFill>
+        <p:spPr>
+          <a:xfrm>
+            <a:off x="4268648" y="2830251"/>
+            <a:ext cx="155448" cy="155448"/>
+          </a:xfrm>
+          <a:prstGeom prst="rect">
+            <a:avLst/>
+          </a:prstGeom>
+        </p:spPr>
+      </p:pic>
+      <p:sp>
+        <p:nvSpPr>
+          <p:cNvPr id="70" name="Text 61"/>
+          <p:cNvSpPr txBox="1"/>
+          <p:nvPr/>
+        </p:nvSpPr>
+        <p:spPr>
+          <a:xfrm>
+            <a:off x="4488104" y="2798247"/>
+            <a:ext cx="2092376" cy="219456"/>
           </a:xfrm>
           <a:prstGeom prst="rect">
             <a:avLst/>
@@ -12966,7 +13182,7 @@
       </p:sp>
       <p:sp>
         <p:nvSpPr>
-          <p:cNvPr id="65" name="Shape 62"/>
+          <p:cNvPr id="71" name="Shape 62"/>
           <p:cNvSpPr/>
           <p:nvPr/>
         </p:nvSpPr>
@@ -12986,7 +13202,7 @@
       </p:sp>
       <p:sp>
         <p:nvSpPr>
-          <p:cNvPr id="66" name="Text 63"/>
+          <p:cNvPr id="72" name="Text 63"/>
           <p:cNvSpPr txBox="1"/>
           <p:nvPr/>
         </p:nvSpPr>
@@ -13028,7 +13244,7 @@
       </p:sp>
       <p:sp>
         <p:nvSpPr>
-          <p:cNvPr id="67" name="Shape 64"/>
+          <p:cNvPr id="73" name="Shape 64"/>
           <p:cNvSpPr/>
           <p:nvPr/>
         </p:nvSpPr>
@@ -13048,7 +13264,7 @@
       </p:sp>
       <p:sp>
         <p:nvSpPr>
-          <p:cNvPr id="68" name="Text 65"/>
+          <p:cNvPr id="74" name="Text 65"/>
           <p:cNvSpPr txBox="1"/>
           <p:nvPr/>
         </p:nvSpPr>
@@ -13090,7 +13306,7 @@
       </p:sp>
       <p:sp>
         <p:nvSpPr>
-          <p:cNvPr id="69" name="Shape 66"/>
+          <p:cNvPr id="75" name="Shape 66"/>
           <p:cNvSpPr/>
           <p:nvPr/>
         </p:nvSpPr>
@@ -13110,7 +13326,7 @@
       </p:sp>
       <p:sp>
         <p:nvSpPr>
-          <p:cNvPr id="70" name="Text 67"/>
+          <p:cNvPr id="76" name="Text 67"/>
           <p:cNvSpPr txBox="1"/>
           <p:nvPr/>
         </p:nvSpPr>
@@ -13152,7 +13368,7 @@
       </p:sp>
       <p:sp>
         <p:nvSpPr>
-          <p:cNvPr id="71" name="Shape 68"/>
+          <p:cNvPr id="77" name="Shape 68"/>
           <p:cNvSpPr/>
           <p:nvPr/>
         </p:nvSpPr>
@@ -13172,7 +13388,7 @@
       </p:sp>
       <p:sp>
         <p:nvSpPr>
-          <p:cNvPr id="72" name="Text 69"/>
+          <p:cNvPr id="78" name="Text 69"/>
           <p:cNvSpPr txBox="1"/>
           <p:nvPr/>
         </p:nvSpPr>
@@ -13214,7 +13430,7 @@
       </p:sp>
       <p:sp>
         <p:nvSpPr>
-          <p:cNvPr id="73" name="Shape 70"/>
+          <p:cNvPr id="79" name="Shape 70"/>
           <p:cNvSpPr/>
           <p:nvPr/>
         </p:nvSpPr>
@@ -13234,7 +13450,7 @@
       </p:sp>
       <p:sp>
         <p:nvSpPr>
-          <p:cNvPr id="74" name="Text 71"/>
+          <p:cNvPr id="80" name="Text 71"/>
           <p:cNvSpPr txBox="1"/>
           <p:nvPr/>
         </p:nvSpPr>
@@ -13276,7 +13492,7 @@
       </p:sp>
       <p:sp>
         <p:nvSpPr>
-          <p:cNvPr id="75" name="Shape 72"/>
+          <p:cNvPr id="81" name="Shape 72"/>
           <p:cNvSpPr/>
           <p:nvPr/>
         </p:nvSpPr>
@@ -13298,7 +13514,7 @@
       </p:sp>
       <p:sp>
         <p:nvSpPr>
-          <p:cNvPr id="76" name="Text 73"/>
+          <p:cNvPr id="82" name="Text 73"/>
           <p:cNvSpPr txBox="1"/>
           <p:nvPr/>
         </p:nvSpPr>
@@ -13340,7 +13556,7 @@
       </p:sp>
       <p:sp>
         <p:nvSpPr>
-          <p:cNvPr id="77" name="Shape 74"/>
+          <p:cNvPr id="83" name="Shape 74"/>
           <p:cNvSpPr/>
           <p:nvPr/>
         </p:nvSpPr>
@@ -13365,7 +13581,7 @@
       </p:sp>
       <p:sp>
         <p:nvSpPr>
-          <p:cNvPr id="78" name="Shape 75"/>
+          <p:cNvPr id="84" name="Shape 75"/>
           <p:cNvSpPr/>
           <p:nvPr/>
         </p:nvSpPr>
@@ -13392,7 +13608,7 @@
       </p:sp>
       <p:sp>
         <p:nvSpPr>
-          <p:cNvPr id="79" name="Shape 76"/>
+          <p:cNvPr id="85" name="Shape 76"/>
           <p:cNvSpPr/>
           <p:nvPr/>
         </p:nvSpPr>
@@ -13412,7 +13628,7 @@
       </p:sp>
       <p:sp>
         <p:nvSpPr>
-          <p:cNvPr id="80" name="Text 77"/>
+          <p:cNvPr id="86" name="Text 77"/>
           <p:cNvSpPr txBox="1"/>
           <p:nvPr/>
         </p:nvSpPr>
@@ -13454,7 +13670,7 @@
       </p:sp>
       <p:sp>
         <p:nvSpPr>
-          <p:cNvPr id="81" name="Text 78"/>
+          <p:cNvPr id="87" name="Text 78"/>
           <p:cNvSpPr txBox="1"/>
           <p:nvPr/>
         </p:nvSpPr>
@@ -13494,16 +13710,40 @@
           </a:p>
         </p:txBody>
       </p:sp>
-      <p:sp>
-        <p:nvSpPr>
-          <p:cNvPr id="82" name="Text 79"/>
-          <p:cNvSpPr txBox="1"/>
-          <p:nvPr/>
-        </p:nvSpPr>
-        <p:spPr>
-          <a:xfrm>
-            <a:off x="6891376" y="1161288"/>
-            <a:ext cx="2311832" cy="219456"/>
+      <p:pic>
+        <p:nvPicPr>
+          <p:cNvPr id="88" name="Image 7" descr="preencoded.png">    </p:cNvPr>
+          <p:cNvPicPr>
+            <a:picLocks noChangeAspect="1"/>
+          </p:cNvPicPr>
+          <p:nvPr/>
+        </p:nvPicPr>
+        <p:blipFill>
+          <a:blip r:embed="rId8"/>
+          <a:stretch>
+            <a:fillRect/>
+          </a:stretch>
+        </p:blipFill>
+        <p:spPr>
+          <a:xfrm>
+            <a:off x="6891376" y="1193292"/>
+            <a:ext cx="155448" cy="155448"/>
+          </a:xfrm>
+          <a:prstGeom prst="rect">
+            <a:avLst/>
+          </a:prstGeom>
+        </p:spPr>
+      </p:pic>
+      <p:sp>
+        <p:nvSpPr>
+          <p:cNvPr id="89" name="Text 79"/>
+          <p:cNvSpPr txBox="1"/>
+          <p:nvPr/>
+        </p:nvSpPr>
+        <p:spPr>
+          <a:xfrm>
+            <a:off x="7110832" y="1161288"/>
+            <a:ext cx="2092376" cy="219456"/>
           </a:xfrm>
           <a:prstGeom prst="rect">
             <a:avLst/>
@@ -13538,7 +13778,7 @@
       </p:sp>
       <p:sp>
         <p:nvSpPr>
-          <p:cNvPr id="83" name="Shape 80"/>
+          <p:cNvPr id="90" name="Shape 80"/>
           <p:cNvSpPr/>
           <p:nvPr/>
         </p:nvSpPr>
@@ -13558,7 +13798,7 @@
       </p:sp>
       <p:sp>
         <p:nvSpPr>
-          <p:cNvPr id="84" name="Text 81"/>
+          <p:cNvPr id="91" name="Text 81"/>
           <p:cNvSpPr txBox="1"/>
           <p:nvPr/>
         </p:nvSpPr>
@@ -13600,7 +13840,7 @@
       </p:sp>
       <p:sp>
         <p:nvSpPr>
-          <p:cNvPr id="85" name="Shape 82"/>
+          <p:cNvPr id="92" name="Shape 82"/>
           <p:cNvSpPr/>
           <p:nvPr/>
         </p:nvSpPr>
@@ -13620,7 +13860,7 @@
       </p:sp>
       <p:sp>
         <p:nvSpPr>
-          <p:cNvPr id="86" name="Text 83"/>
+          <p:cNvPr id="93" name="Text 83"/>
           <p:cNvSpPr txBox="1"/>
           <p:nvPr/>
         </p:nvSpPr>
@@ -13662,7 +13902,7 @@
       </p:sp>
       <p:sp>
         <p:nvSpPr>
-          <p:cNvPr id="87" name="Shape 84"/>
+          <p:cNvPr id="94" name="Shape 84"/>
           <p:cNvSpPr/>
           <p:nvPr/>
         </p:nvSpPr>
@@ -13682,7 +13922,7 @@
       </p:sp>
       <p:sp>
         <p:nvSpPr>
-          <p:cNvPr id="88" name="Text 85"/>
+          <p:cNvPr id="95" name="Text 85"/>
           <p:cNvSpPr txBox="1"/>
           <p:nvPr/>
         </p:nvSpPr>
@@ -13724,7 +13964,7 @@
       </p:sp>
       <p:sp>
         <p:nvSpPr>
-          <p:cNvPr id="89" name="Shape 86"/>
+          <p:cNvPr id="96" name="Shape 86"/>
           <p:cNvSpPr/>
           <p:nvPr/>
         </p:nvSpPr>
@@ -13744,7 +13984,7 @@
       </p:sp>
       <p:sp>
         <p:nvSpPr>
-          <p:cNvPr id="90" name="Text 87"/>
+          <p:cNvPr id="97" name="Text 87"/>
           <p:cNvSpPr txBox="1"/>
           <p:nvPr/>
         </p:nvSpPr>
@@ -13784,16 +14024,40 @@
           </a:p>
         </p:txBody>
       </p:sp>
-      <p:sp>
-        <p:nvSpPr>
-          <p:cNvPr id="91" name="Text 88"/>
-          <p:cNvSpPr txBox="1"/>
-          <p:nvPr/>
-        </p:nvSpPr>
-        <p:spPr>
-          <a:xfrm>
-            <a:off x="6891376" y="2103120"/>
-            <a:ext cx="2311832" cy="219456"/>
+      <p:pic>
+        <p:nvPicPr>
+          <p:cNvPr id="98" name="Image 8" descr="preencoded.png">    </p:cNvPr>
+          <p:cNvPicPr>
+            <a:picLocks noChangeAspect="1"/>
+          </p:cNvPicPr>
+          <p:nvPr/>
+        </p:nvPicPr>
+        <p:blipFill>
+          <a:blip r:embed="rId9"/>
+          <a:stretch>
+            <a:fillRect/>
+          </a:stretch>
+        </p:blipFill>
+        <p:spPr>
+          <a:xfrm>
+            <a:off x="6891376" y="2135124"/>
+            <a:ext cx="155448" cy="155448"/>
+          </a:xfrm>
+          <a:prstGeom prst="rect">
+            <a:avLst/>
+          </a:prstGeom>
+        </p:spPr>
+      </p:pic>
+      <p:sp>
+        <p:nvSpPr>
+          <p:cNvPr id="99" name="Text 88"/>
+          <p:cNvSpPr txBox="1"/>
+          <p:nvPr/>
+        </p:nvSpPr>
+        <p:spPr>
+          <a:xfrm>
+            <a:off x="7110832" y="2103120"/>
+            <a:ext cx="2092376" cy="219456"/>
           </a:xfrm>
           <a:prstGeom prst="rect">
             <a:avLst/>
@@ -13828,7 +14092,7 @@
       </p:sp>
       <p:sp>
         <p:nvSpPr>
-          <p:cNvPr id="92" name="Shape 89"/>
+          <p:cNvPr id="100" name="Shape 89"/>
           <p:cNvSpPr/>
           <p:nvPr/>
         </p:nvSpPr>
@@ -13848,7 +14112,7 @@
       </p:sp>
       <p:sp>
         <p:nvSpPr>
-          <p:cNvPr id="93" name="Text 90"/>
+          <p:cNvPr id="101" name="Text 90"/>
           <p:cNvSpPr txBox="1"/>
           <p:nvPr/>
         </p:nvSpPr>
@@ -13890,7 +14154,7 @@
       </p:sp>
       <p:sp>
         <p:nvSpPr>
-          <p:cNvPr id="94" name="Shape 91"/>
+          <p:cNvPr id="102" name="Shape 91"/>
           <p:cNvSpPr/>
           <p:nvPr/>
         </p:nvSpPr>
@@ -13910,7 +14174,7 @@
       </p:sp>
       <p:sp>
         <p:nvSpPr>
-          <p:cNvPr id="95" name="Text 92"/>
+          <p:cNvPr id="103" name="Text 92"/>
           <p:cNvSpPr txBox="1"/>
           <p:nvPr/>
         </p:nvSpPr>
@@ -13950,16 +14214,40 @@
           </a:p>
         </p:txBody>
       </p:sp>
-      <p:sp>
-        <p:nvSpPr>
-          <p:cNvPr id="96" name="Text 93"/>
-          <p:cNvSpPr txBox="1"/>
-          <p:nvPr/>
-        </p:nvSpPr>
-        <p:spPr>
-          <a:xfrm>
-            <a:off x="6891376" y="2971983"/>
-            <a:ext cx="2311832" cy="219456"/>
+      <p:pic>
+        <p:nvPicPr>
+          <p:cNvPr id="104" name="Image 9" descr="preencoded.png">    </p:cNvPr>
+          <p:cNvPicPr>
+            <a:picLocks noChangeAspect="1"/>
+          </p:cNvPicPr>
+          <p:nvPr/>
+        </p:nvPicPr>
+        <p:blipFill>
+          <a:blip r:embed="rId10"/>
+          <a:stretch>
+            <a:fillRect/>
+          </a:stretch>
+        </p:blipFill>
+        <p:spPr>
+          <a:xfrm>
+            <a:off x="6891376" y="3003987"/>
+            <a:ext cx="155448" cy="155448"/>
+          </a:xfrm>
+          <a:prstGeom prst="rect">
+            <a:avLst/>
+          </a:prstGeom>
+        </p:spPr>
+      </p:pic>
+      <p:sp>
+        <p:nvSpPr>
+          <p:cNvPr id="105" name="Text 93"/>
+          <p:cNvSpPr txBox="1"/>
+          <p:nvPr/>
+        </p:nvSpPr>
+        <p:spPr>
+          <a:xfrm>
+            <a:off x="7110832" y="2971983"/>
+            <a:ext cx="2092376" cy="219456"/>
           </a:xfrm>
           <a:prstGeom prst="rect">
             <a:avLst/>
@@ -13994,7 +14282,7 @@
       </p:sp>
       <p:sp>
         <p:nvSpPr>
-          <p:cNvPr id="97" name="Shape 94"/>
+          <p:cNvPr id="106" name="Shape 94"/>
           <p:cNvSpPr/>
           <p:nvPr/>
         </p:nvSpPr>
@@ -14014,7 +14302,7 @@
       </p:sp>
       <p:sp>
         <p:nvSpPr>
-          <p:cNvPr id="98" name="Text 95"/>
+          <p:cNvPr id="107" name="Text 95"/>
           <p:cNvSpPr txBox="1"/>
           <p:nvPr/>
         </p:nvSpPr>
@@ -14056,7 +14344,7 @@
       </p:sp>
       <p:sp>
         <p:nvSpPr>
-          <p:cNvPr id="99" name="Shape 96"/>
+          <p:cNvPr id="108" name="Shape 96"/>
           <p:cNvSpPr/>
           <p:nvPr/>
         </p:nvSpPr>
@@ -14076,7 +14364,7 @@
       </p:sp>
       <p:sp>
         <p:nvSpPr>
-          <p:cNvPr id="100" name="Text 97"/>
+          <p:cNvPr id="109" name="Text 97"/>
           <p:cNvSpPr txBox="1"/>
           <p:nvPr/>
         </p:nvSpPr>
@@ -14118,7 +14406,7 @@
       </p:sp>
       <p:sp>
         <p:nvSpPr>
-          <p:cNvPr id="101" name="Shape 98"/>
+          <p:cNvPr id="110" name="Shape 98"/>
           <p:cNvSpPr/>
           <p:nvPr/>
         </p:nvSpPr>
@@ -14138,7 +14426,7 @@
       </p:sp>
       <p:sp>
         <p:nvSpPr>
-          <p:cNvPr id="102" name="Text 99"/>
+          <p:cNvPr id="111" name="Text 99"/>
           <p:cNvSpPr txBox="1"/>
           <p:nvPr/>
         </p:nvSpPr>
@@ -14180,7 +14468,7 @@
       </p:sp>
       <p:sp>
         <p:nvSpPr>
-          <p:cNvPr id="103" name="Shape 100"/>
+          <p:cNvPr id="112" name="Shape 100"/>
           <p:cNvSpPr/>
           <p:nvPr/>
         </p:nvSpPr>
@@ -14200,7 +14488,7 @@
       </p:sp>
       <p:sp>
         <p:nvSpPr>
-          <p:cNvPr id="104" name="Text 101"/>
+          <p:cNvPr id="113" name="Text 101"/>
           <p:cNvSpPr txBox="1"/>
           <p:nvPr/>
         </p:nvSpPr>
@@ -14242,7 +14530,7 @@
       </p:sp>
       <p:sp>
         <p:nvSpPr>
-          <p:cNvPr id="105" name="Shape 102"/>
+          <p:cNvPr id="114" name="Shape 102"/>
           <p:cNvSpPr/>
           <p:nvPr/>
         </p:nvSpPr>
@@ -14262,7 +14550,7 @@
       </p:sp>
       <p:sp>
         <p:nvSpPr>
-          <p:cNvPr id="106" name="Text 103"/>
+          <p:cNvPr id="115" name="Text 103"/>
           <p:cNvSpPr txBox="1"/>
           <p:nvPr/>
         </p:nvSpPr>
@@ -14304,7 +14592,7 @@
       </p:sp>
       <p:sp>
         <p:nvSpPr>
-          <p:cNvPr id="107" name="Shape 104"/>
+          <p:cNvPr id="116" name="Shape 104"/>
           <p:cNvSpPr/>
           <p:nvPr/>
         </p:nvSpPr>
@@ -14324,7 +14612,7 @@
       </p:sp>
       <p:sp>
         <p:nvSpPr>
-          <p:cNvPr id="108" name="Text 105"/>
+          <p:cNvPr id="117" name="Text 105"/>
           <p:cNvSpPr txBox="1"/>
           <p:nvPr/>
         </p:nvSpPr>
@@ -14366,7 +14654,7 @@
       </p:sp>
       <p:sp>
         <p:nvSpPr>
-          <p:cNvPr id="109" name="Shape 106"/>
+          <p:cNvPr id="118" name="Shape 106"/>
           <p:cNvSpPr/>
           <p:nvPr/>
         </p:nvSpPr>
@@ -14388,7 +14676,7 @@
       </p:sp>
       <p:sp>
         <p:nvSpPr>
-          <p:cNvPr id="110" name="Text 107"/>
+          <p:cNvPr id="119" name="Text 107"/>
           <p:cNvSpPr txBox="1"/>
           <p:nvPr/>
         </p:nvSpPr>
@@ -14430,7 +14718,7 @@
       </p:sp>
       <p:sp>
         <p:nvSpPr>
-          <p:cNvPr id="111" name="Shape 108"/>
+          <p:cNvPr id="120" name="Shape 108"/>
           <p:cNvSpPr/>
           <p:nvPr/>
         </p:nvSpPr>
@@ -14455,7 +14743,7 @@
       </p:sp>
       <p:sp>
         <p:nvSpPr>
-          <p:cNvPr id="112" name="Shape 109"/>
+          <p:cNvPr id="121" name="Shape 109"/>
           <p:cNvSpPr/>
           <p:nvPr/>
         </p:nvSpPr>
@@ -14482,7 +14770,7 @@
       </p:sp>
       <p:sp>
         <p:nvSpPr>
-          <p:cNvPr id="113" name="Shape 110"/>
+          <p:cNvPr id="122" name="Shape 110"/>
           <p:cNvSpPr/>
           <p:nvPr/>
         </p:nvSpPr>
@@ -14502,7 +14790,7 @@
       </p:sp>
       <p:sp>
         <p:nvSpPr>
-          <p:cNvPr id="114" name="Text 111"/>
+          <p:cNvPr id="123" name="Text 111"/>
           <p:cNvSpPr txBox="1"/>
           <p:nvPr/>
         </p:nvSpPr>
@@ -14544,7 +14832,7 @@
       </p:sp>
       <p:sp>
         <p:nvSpPr>
-          <p:cNvPr id="115" name="Text 112"/>
+          <p:cNvPr id="124" name="Text 112"/>
           <p:cNvSpPr txBox="1"/>
           <p:nvPr/>
         </p:nvSpPr>
@@ -14584,16 +14872,40 @@
           </a:p>
         </p:txBody>
       </p:sp>
-      <p:sp>
-        <p:nvSpPr>
-          <p:cNvPr id="116" name="Text 113"/>
-          <p:cNvSpPr txBox="1"/>
-          <p:nvPr/>
-        </p:nvSpPr>
-        <p:spPr>
-          <a:xfrm>
-            <a:off x="9514103" y="1161288"/>
-            <a:ext cx="2311832" cy="219456"/>
+      <p:pic>
+        <p:nvPicPr>
+          <p:cNvPr id="125" name="Image 10" descr="preencoded.png">    </p:cNvPr>
+          <p:cNvPicPr>
+            <a:picLocks noChangeAspect="1"/>
+          </p:cNvPicPr>
+          <p:nvPr/>
+        </p:nvPicPr>
+        <p:blipFill>
+          <a:blip r:embed="rId11"/>
+          <a:stretch>
+            <a:fillRect/>
+          </a:stretch>
+        </p:blipFill>
+        <p:spPr>
+          <a:xfrm>
+            <a:off x="9514103" y="1193292"/>
+            <a:ext cx="155448" cy="155448"/>
+          </a:xfrm>
+          <a:prstGeom prst="rect">
+            <a:avLst/>
+          </a:prstGeom>
+        </p:spPr>
+      </p:pic>
+      <p:sp>
+        <p:nvSpPr>
+          <p:cNvPr id="126" name="Text 113"/>
+          <p:cNvSpPr txBox="1"/>
+          <p:nvPr/>
+        </p:nvSpPr>
+        <p:spPr>
+          <a:xfrm>
+            <a:off x="9733559" y="1161288"/>
+            <a:ext cx="2092376" cy="219456"/>
           </a:xfrm>
           <a:prstGeom prst="rect">
             <a:avLst/>
@@ -14628,7 +14940,7 @@
       </p:sp>
       <p:sp>
         <p:nvSpPr>
-          <p:cNvPr id="117" name="Shape 114"/>
+          <p:cNvPr id="127" name="Shape 114"/>
           <p:cNvSpPr/>
           <p:nvPr/>
         </p:nvSpPr>
@@ -14648,7 +14960,7 @@
       </p:sp>
       <p:sp>
         <p:nvSpPr>
-          <p:cNvPr id="118" name="Text 115"/>
+          <p:cNvPr id="128" name="Text 115"/>
           <p:cNvSpPr txBox="1"/>
           <p:nvPr/>
         </p:nvSpPr>
@@ -14690,7 +15002,7 @@
       </p:sp>
       <p:sp>
         <p:nvSpPr>
-          <p:cNvPr id="119" name="Shape 116"/>
+          <p:cNvPr id="129" name="Shape 116"/>
           <p:cNvSpPr/>
           <p:nvPr/>
         </p:nvSpPr>
@@ -14710,7 +15022,7 @@
       </p:sp>
       <p:sp>
         <p:nvSpPr>
-          <p:cNvPr id="120" name="Text 117"/>
+          <p:cNvPr id="130" name="Text 117"/>
           <p:cNvSpPr txBox="1"/>
           <p:nvPr/>
         </p:nvSpPr>
@@ -14752,7 +15064,7 @@
       </p:sp>
       <p:sp>
         <p:nvSpPr>
-          <p:cNvPr id="121" name="Shape 118"/>
+          <p:cNvPr id="131" name="Shape 118"/>
           <p:cNvSpPr/>
           <p:nvPr/>
         </p:nvSpPr>
@@ -14772,7 +15084,7 @@
       </p:sp>
       <p:sp>
         <p:nvSpPr>
-          <p:cNvPr id="122" name="Text 119"/>
+          <p:cNvPr id="132" name="Text 119"/>
           <p:cNvSpPr txBox="1"/>
           <p:nvPr/>
         </p:nvSpPr>
@@ -14814,7 +15126,7 @@
       </p:sp>
       <p:sp>
         <p:nvSpPr>
-          <p:cNvPr id="123" name="Shape 120"/>
+          <p:cNvPr id="133" name="Shape 120"/>
           <p:cNvSpPr/>
           <p:nvPr/>
         </p:nvSpPr>
@@ -14834,7 +15146,7 @@
       </p:sp>
       <p:sp>
         <p:nvSpPr>
-          <p:cNvPr id="124" name="Text 121"/>
+          <p:cNvPr id="134" name="Text 121"/>
           <p:cNvSpPr txBox="1"/>
           <p:nvPr/>
         </p:nvSpPr>
@@ -14874,16 +15186,40 @@
           </a:p>
         </p:txBody>
       </p:sp>
-      <p:sp>
-        <p:nvSpPr>
-          <p:cNvPr id="125" name="Text 122"/>
-          <p:cNvSpPr txBox="1"/>
-          <p:nvPr/>
-        </p:nvSpPr>
-        <p:spPr>
-          <a:xfrm>
-            <a:off x="9514103" y="2103120"/>
-            <a:ext cx="2311832" cy="219456"/>
+      <p:pic>
+        <p:nvPicPr>
+          <p:cNvPr id="135" name="Image 11" descr="preencoded.png">    </p:cNvPr>
+          <p:cNvPicPr>
+            <a:picLocks noChangeAspect="1"/>
+          </p:cNvPicPr>
+          <p:nvPr/>
+        </p:nvPicPr>
+        <p:blipFill>
+          <a:blip r:embed="rId12"/>
+          <a:stretch>
+            <a:fillRect/>
+          </a:stretch>
+        </p:blipFill>
+        <p:spPr>
+          <a:xfrm>
+            <a:off x="9514103" y="2135124"/>
+            <a:ext cx="155448" cy="155448"/>
+          </a:xfrm>
+          <a:prstGeom prst="rect">
+            <a:avLst/>
+          </a:prstGeom>
+        </p:spPr>
+      </p:pic>
+      <p:sp>
+        <p:nvSpPr>
+          <p:cNvPr id="136" name="Text 122"/>
+          <p:cNvSpPr txBox="1"/>
+          <p:nvPr/>
+        </p:nvSpPr>
+        <p:spPr>
+          <a:xfrm>
+            <a:off x="9733559" y="2103120"/>
+            <a:ext cx="2092376" cy="219456"/>
           </a:xfrm>
           <a:prstGeom prst="rect">
             <a:avLst/>
@@ -14918,7 +15254,7 @@
       </p:sp>
       <p:sp>
         <p:nvSpPr>
-          <p:cNvPr id="126" name="Shape 123"/>
+          <p:cNvPr id="137" name="Shape 123"/>
           <p:cNvSpPr/>
           <p:nvPr/>
         </p:nvSpPr>
@@ -14938,7 +15274,7 @@
       </p:sp>
       <p:sp>
         <p:nvSpPr>
-          <p:cNvPr id="127" name="Text 124"/>
+          <p:cNvPr id="138" name="Text 124"/>
           <p:cNvSpPr txBox="1"/>
           <p:nvPr/>
         </p:nvSpPr>
@@ -14980,7 +15316,7 @@
       </p:sp>
       <p:sp>
         <p:nvSpPr>
-          <p:cNvPr id="128" name="Shape 125"/>
+          <p:cNvPr id="139" name="Shape 125"/>
           <p:cNvSpPr/>
           <p:nvPr/>
         </p:nvSpPr>
@@ -15000,7 +15336,7 @@
       </p:sp>
       <p:sp>
         <p:nvSpPr>
-          <p:cNvPr id="129" name="Text 126"/>
+          <p:cNvPr id="140" name="Text 126"/>
           <p:cNvSpPr txBox="1"/>
           <p:nvPr/>
         </p:nvSpPr>
@@ -15040,16 +15376,40 @@
           </a:p>
         </p:txBody>
       </p:sp>
-      <p:sp>
-        <p:nvSpPr>
-          <p:cNvPr id="130" name="Text 127"/>
-          <p:cNvSpPr txBox="1"/>
-          <p:nvPr/>
-        </p:nvSpPr>
-        <p:spPr>
-          <a:xfrm>
-            <a:off x="9514103" y="2971983"/>
-            <a:ext cx="2311832" cy="219456"/>
+      <p:pic>
+        <p:nvPicPr>
+          <p:cNvPr id="141" name="Image 12" descr="preencoded.png">    </p:cNvPr>
+          <p:cNvPicPr>
+            <a:picLocks noChangeAspect="1"/>
+          </p:cNvPicPr>
+          <p:nvPr/>
+        </p:nvPicPr>
+        <p:blipFill>
+          <a:blip r:embed="rId13"/>
+          <a:stretch>
+            <a:fillRect/>
+          </a:stretch>
+        </p:blipFill>
+        <p:spPr>
+          <a:xfrm>
+            <a:off x="9514103" y="3003987"/>
+            <a:ext cx="155448" cy="155448"/>
+          </a:xfrm>
+          <a:prstGeom prst="rect">
+            <a:avLst/>
+          </a:prstGeom>
+        </p:spPr>
+      </p:pic>
+      <p:sp>
+        <p:nvSpPr>
+          <p:cNvPr id="142" name="Text 127"/>
+          <p:cNvSpPr txBox="1"/>
+          <p:nvPr/>
+        </p:nvSpPr>
+        <p:spPr>
+          <a:xfrm>
+            <a:off x="9733559" y="2971983"/>
+            <a:ext cx="2092376" cy="219456"/>
           </a:xfrm>
           <a:prstGeom prst="rect">
             <a:avLst/>
@@ -15084,7 +15444,7 @@
       </p:sp>
       <p:sp>
         <p:nvSpPr>
-          <p:cNvPr id="131" name="Shape 128"/>
+          <p:cNvPr id="143" name="Shape 128"/>
           <p:cNvSpPr/>
           <p:nvPr/>
         </p:nvSpPr>
@@ -15104,7 +15464,7 @@
       </p:sp>
       <p:sp>
         <p:nvSpPr>
-          <p:cNvPr id="132" name="Text 129"/>
+          <p:cNvPr id="144" name="Text 129"/>
           <p:cNvSpPr txBox="1"/>
           <p:nvPr/>
         </p:nvSpPr>
@@ -15146,7 +15506,7 @@
       </p:sp>
       <p:sp>
         <p:nvSpPr>
-          <p:cNvPr id="133" name="Shape 130"/>
+          <p:cNvPr id="145" name="Shape 130"/>
           <p:cNvSpPr/>
           <p:nvPr/>
         </p:nvSpPr>
@@ -15166,7 +15526,7 @@
       </p:sp>
       <p:sp>
         <p:nvSpPr>
-          <p:cNvPr id="134" name="Text 131"/>
+          <p:cNvPr id="146" name="Text 131"/>
           <p:cNvSpPr txBox="1"/>
           <p:nvPr/>
         </p:nvSpPr>
@@ -15208,7 +15568,7 @@
       </p:sp>
       <p:sp>
         <p:nvSpPr>
-          <p:cNvPr id="135" name="Shape 132"/>
+          <p:cNvPr id="147" name="Shape 132"/>
           <p:cNvSpPr/>
           <p:nvPr/>
         </p:nvSpPr>
@@ -15228,7 +15588,7 @@
       </p:sp>
       <p:sp>
         <p:nvSpPr>
-          <p:cNvPr id="136" name="Text 133"/>
+          <p:cNvPr id="148" name="Text 133"/>
           <p:cNvSpPr txBox="1"/>
           <p:nvPr/>
         </p:nvSpPr>
@@ -15270,7 +15630,7 @@
       </p:sp>
       <p:sp>
         <p:nvSpPr>
-          <p:cNvPr id="137" name="Shape 134"/>
+          <p:cNvPr id="149" name="Shape 134"/>
           <p:cNvSpPr/>
           <p:nvPr/>
         </p:nvSpPr>
@@ -15290,7 +15650,7 @@
       </p:sp>
       <p:sp>
         <p:nvSpPr>
-          <p:cNvPr id="138" name="Text 135"/>
+          <p:cNvPr id="150" name="Text 135"/>
           <p:cNvSpPr txBox="1"/>
           <p:nvPr/>
         </p:nvSpPr>
@@ -15332,7 +15692,7 @@
       </p:sp>
       <p:sp>
         <p:nvSpPr>
-          <p:cNvPr id="139" name="Shape 136"/>
+          <p:cNvPr id="151" name="Shape 136"/>
           <p:cNvSpPr/>
           <p:nvPr/>
         </p:nvSpPr>
@@ -15352,7 +15712,7 @@
       </p:sp>
       <p:sp>
         <p:nvSpPr>
-          <p:cNvPr id="140" name="Text 137"/>
+          <p:cNvPr id="152" name="Text 137"/>
           <p:cNvSpPr txBox="1"/>
           <p:nvPr/>
         </p:nvSpPr>
@@ -15394,7 +15754,7 @@
       </p:sp>
       <p:sp>
         <p:nvSpPr>
-          <p:cNvPr id="141" name="Shape 138"/>
+          <p:cNvPr id="153" name="Shape 138"/>
           <p:cNvSpPr/>
           <p:nvPr/>
         </p:nvSpPr>
@@ -15416,7 +15776,7 @@
       </p:sp>
       <p:sp>
         <p:nvSpPr>
-          <p:cNvPr id="142" name="Text 139"/>
+          <p:cNvPr id="154" name="Text 139"/>
           <p:cNvSpPr txBox="1"/>
           <p:nvPr/>
         </p:nvSpPr>
@@ -15458,7 +15818,7 @@
       </p:sp>
       <p:sp>
         <p:nvSpPr>
-          <p:cNvPr id="143" name="Shape 140"/>
+          <p:cNvPr id="155" name="Shape 140"/>
           <p:cNvSpPr/>
           <p:nvPr/>
         </p:nvSpPr>
@@ -15485,14 +15845,14 @@
       </p:sp>
       <p:pic>
         <p:nvPicPr>
-          <p:cNvPr id="144" name="Image 1" descr="preencoded.png">    </p:cNvPr>
+          <p:cNvPr id="156" name="Image 13" descr="preencoded.png">    </p:cNvPr>
           <p:cNvPicPr>
             <a:picLocks noChangeAspect="1"/>
           </p:cNvPicPr>
           <p:nvPr/>
         </p:nvPicPr>
         <p:blipFill>
-          <a:blip r:embed="rId2"/>
+          <a:blip r:embed="rId14"/>
           <a:stretch>
             <a:fillRect/>
           </a:stretch>
@@ -15509,7 +15869,7 @@
       </p:pic>
       <p:sp>
         <p:nvSpPr>
-          <p:cNvPr id="145" name="Text 141"/>
+          <p:cNvPr id="157" name="Text 141"/>
           <p:cNvSpPr txBox="1"/>
           <p:nvPr/>
         </p:nvSpPr>
@@ -15551,22 +15911,22 @@
       </p:sp>
       <p:pic>
         <p:nvPicPr>
-          <p:cNvPr id="146" name="Image 2" descr="preencoded.png">    </p:cNvPr>
+          <p:cNvPr id="158" name="Image 14" descr="preencoded.png">    </p:cNvPr>
           <p:cNvPicPr>
             <a:picLocks noChangeAspect="1"/>
           </p:cNvPicPr>
           <p:nvPr/>
         </p:nvPicPr>
         <p:blipFill>
-          <a:blip r:embed="rId3"/>
+          <a:blip r:embed="rId15"/>
           <a:stretch>
             <a:fillRect/>
           </a:stretch>
         </p:blipFill>
         <p:spPr>
           <a:xfrm>
-            <a:off x="2651760" y="5468112"/>
-            <a:ext cx="164592" cy="164592"/>
+            <a:off x="2651760" y="5458968"/>
+            <a:ext cx="182880" cy="182880"/>
           </a:xfrm>
           <a:prstGeom prst="rect">
             <a:avLst/>
@@ -15575,7 +15935,7 @@
       </p:pic>
       <p:sp>
         <p:nvSpPr>
-          <p:cNvPr id="147" name="Text 142"/>
+          <p:cNvPr id="159" name="Text 142"/>
           <p:cNvSpPr txBox="1"/>
           <p:nvPr/>
         </p:nvSpPr>
@@ -15617,22 +15977,22 @@
       </p:sp>
       <p:pic>
         <p:nvPicPr>
-          <p:cNvPr id="148" name="Image 3" descr="preencoded.png">    </p:cNvPr>
+          <p:cNvPr id="160" name="Image 15" descr="preencoded.png">    </p:cNvPr>
           <p:cNvPicPr>
             <a:picLocks noChangeAspect="1"/>
           </p:cNvPicPr>
           <p:nvPr/>
         </p:nvPicPr>
         <p:blipFill>
-          <a:blip r:embed="rId4"/>
+          <a:blip r:embed="rId16"/>
           <a:stretch>
             <a:fillRect/>
           </a:stretch>
         </p:blipFill>
         <p:spPr>
           <a:xfrm>
-            <a:off x="4945304" y="5468112"/>
-            <a:ext cx="164592" cy="164592"/>
+            <a:off x="4945304" y="5458968"/>
+            <a:ext cx="182880" cy="182880"/>
           </a:xfrm>
           <a:prstGeom prst="rect">
             <a:avLst/>
@@ -15641,7 +16001,7 @@
       </p:pic>
       <p:sp>
         <p:nvSpPr>
-          <p:cNvPr id="149" name="Text 143"/>
+          <p:cNvPr id="161" name="Text 143"/>
           <p:cNvSpPr txBox="1"/>
           <p:nvPr/>
         </p:nvSpPr>
@@ -15683,22 +16043,22 @@
       </p:sp>
       <p:pic>
         <p:nvPicPr>
-          <p:cNvPr id="150" name="Image 4" descr="preencoded.png">    </p:cNvPr>
+          <p:cNvPr id="162" name="Image 16" descr="preencoded.png">    </p:cNvPr>
           <p:cNvPicPr>
             <a:picLocks noChangeAspect="1"/>
           </p:cNvPicPr>
           <p:nvPr/>
         </p:nvPicPr>
         <p:blipFill>
-          <a:blip r:embed="rId5"/>
+          <a:blip r:embed="rId17"/>
           <a:stretch>
             <a:fillRect/>
           </a:stretch>
         </p:blipFill>
         <p:spPr>
           <a:xfrm>
-            <a:off x="7238848" y="5468112"/>
-            <a:ext cx="164592" cy="164592"/>
+            <a:off x="7238848" y="5458968"/>
+            <a:ext cx="182880" cy="182880"/>
           </a:xfrm>
           <a:prstGeom prst="rect">
             <a:avLst/>
@@ -15707,7 +16067,7 @@
       </p:pic>
       <p:sp>
         <p:nvSpPr>
-          <p:cNvPr id="151" name="Text 144"/>
+          <p:cNvPr id="163" name="Text 144"/>
           <p:cNvSpPr txBox="1"/>
           <p:nvPr/>
         </p:nvSpPr>
@@ -15749,22 +16109,22 @@
       </p:sp>
       <p:pic>
         <p:nvPicPr>
-          <p:cNvPr id="152" name="Image 5" descr="preencoded.png">    </p:cNvPr>
+          <p:cNvPr id="164" name="Image 17" descr="preencoded.png">    </p:cNvPr>
           <p:cNvPicPr>
             <a:picLocks noChangeAspect="1"/>
           </p:cNvPicPr>
           <p:nvPr/>
         </p:nvPicPr>
         <p:blipFill>
-          <a:blip r:embed="rId6"/>
+          <a:blip r:embed="rId18"/>
           <a:stretch>
             <a:fillRect/>
           </a:stretch>
         </p:blipFill>
         <p:spPr>
           <a:xfrm>
-            <a:off x="9532391" y="5468112"/>
-            <a:ext cx="164592" cy="164592"/>
+            <a:off x="9532391" y="5458968"/>
+            <a:ext cx="182880" cy="182880"/>
           </a:xfrm>
           <a:prstGeom prst="rect">
             <a:avLst/>
@@ -15773,7 +16133,7 @@
       </p:pic>
       <p:sp>
         <p:nvSpPr>
-          <p:cNvPr id="153" name="Text 145"/>
+          <p:cNvPr id="165" name="Text 145"/>
           <p:cNvSpPr txBox="1"/>
           <p:nvPr/>
         </p:nvSpPr>
@@ -15815,22 +16175,22 @@
       </p:sp>
       <p:pic>
         <p:nvPicPr>
-          <p:cNvPr id="154" name="Image 6" descr="preencoded.png">    </p:cNvPr>
+          <p:cNvPr id="166" name="Image 18" descr="preencoded.png">    </p:cNvPr>
           <p:cNvPicPr>
             <a:picLocks noChangeAspect="1"/>
           </p:cNvPicPr>
           <p:nvPr/>
         </p:nvPicPr>
         <p:blipFill>
-          <a:blip r:embed="rId7"/>
+          <a:blip r:embed="rId19"/>
           <a:stretch>
             <a:fillRect/>
           </a:stretch>
         </p:blipFill>
         <p:spPr>
           <a:xfrm>
-            <a:off x="2651760" y="5779008"/>
-            <a:ext cx="164592" cy="164592"/>
+            <a:off x="2651760" y="5769864"/>
+            <a:ext cx="182880" cy="182880"/>
           </a:xfrm>
           <a:prstGeom prst="rect">
             <a:avLst/>
@@ -15839,7 +16199,7 @@
       </p:pic>
       <p:sp>
         <p:nvSpPr>
-          <p:cNvPr id="155" name="Text 146"/>
+          <p:cNvPr id="167" name="Text 146"/>
           <p:cNvSpPr txBox="1"/>
           <p:nvPr/>
         </p:nvSpPr>
@@ -15881,22 +16241,22 @@
       </p:sp>
       <p:pic>
         <p:nvPicPr>
-          <p:cNvPr id="156" name="Image 7" descr="preencoded.png">    </p:cNvPr>
+          <p:cNvPr id="168" name="Image 19" descr="preencoded.png">    </p:cNvPr>
           <p:cNvPicPr>
             <a:picLocks noChangeAspect="1"/>
           </p:cNvPicPr>
           <p:nvPr/>
         </p:nvPicPr>
         <p:blipFill>
-          <a:blip r:embed="rId8"/>
+          <a:blip r:embed="rId20"/>
           <a:stretch>
             <a:fillRect/>
           </a:stretch>
         </p:blipFill>
         <p:spPr>
           <a:xfrm>
-            <a:off x="4945304" y="5779008"/>
-            <a:ext cx="164592" cy="164592"/>
+            <a:off x="4945304" y="5769864"/>
+            <a:ext cx="182880" cy="182880"/>
           </a:xfrm>
           <a:prstGeom prst="rect">
             <a:avLst/>
@@ -15905,7 +16265,7 @@
       </p:pic>
       <p:sp>
         <p:nvSpPr>
-          <p:cNvPr id="157" name="Text 147"/>
+          <p:cNvPr id="169" name="Text 147"/>
           <p:cNvSpPr txBox="1"/>
           <p:nvPr/>
         </p:nvSpPr>
@@ -15947,22 +16307,22 @@
       </p:sp>
       <p:pic>
         <p:nvPicPr>
-          <p:cNvPr id="158" name="Image 8" descr="preencoded.png">    </p:cNvPr>
+          <p:cNvPr id="170" name="Image 20" descr="preencoded.png">    </p:cNvPr>
           <p:cNvPicPr>
             <a:picLocks noChangeAspect="1"/>
           </p:cNvPicPr>
           <p:nvPr/>
         </p:nvPicPr>
         <p:blipFill>
-          <a:blip r:embed="rId9"/>
+          <a:blip r:embed="rId21"/>
           <a:stretch>
             <a:fillRect/>
           </a:stretch>
         </p:blipFill>
         <p:spPr>
           <a:xfrm>
-            <a:off x="7238848" y="5779008"/>
-            <a:ext cx="164592" cy="164592"/>
+            <a:off x="7238848" y="5769864"/>
+            <a:ext cx="182880" cy="182880"/>
           </a:xfrm>
           <a:prstGeom prst="rect">
             <a:avLst/>
@@ -15971,7 +16331,7 @@
       </p:pic>
       <p:sp>
         <p:nvSpPr>
-          <p:cNvPr id="159" name="Text 148"/>
+          <p:cNvPr id="171" name="Text 148"/>
           <p:cNvSpPr txBox="1"/>
           <p:nvPr/>
         </p:nvSpPr>
@@ -16013,7 +16373,7 @@
       </p:sp>
       <p:sp>
         <p:nvSpPr>
-          <p:cNvPr id="160" name="Shape 149"/>
+          <p:cNvPr id="172" name="Shape 149"/>
           <p:cNvSpPr/>
           <p:nvPr/>
         </p:nvSpPr>
@@ -16035,14 +16395,14 @@
       </p:sp>
       <p:pic>
         <p:nvPicPr>
-          <p:cNvPr id="161" name="Image 9" descr="preencoded.png">    </p:cNvPr>
+          <p:cNvPr id="173" name="Image 21" descr="preencoded.png">    </p:cNvPr>
           <p:cNvPicPr>
             <a:picLocks noChangeAspect="1"/>
           </p:cNvPicPr>
           <p:nvPr/>
         </p:nvPicPr>
         <p:blipFill>
-          <a:blip r:embed="rId10"/>
+          <a:blip r:embed="rId22"/>
           <a:stretch>
             <a:fillRect/>
           </a:stretch>
@@ -16059,7 +16419,7 @@
       </p:pic>
       <p:sp>
         <p:nvSpPr>
-          <p:cNvPr id="162" name="Text 150"/>
+          <p:cNvPr id="174" name="Text 150"/>
           <p:cNvSpPr txBox="1"/>
           <p:nvPr/>
         </p:nvSpPr>
@@ -33648,9 +34008,33 @@
           </a:prstGeom>
         </p:spPr>
       </p:pic>
-      <p:sp>
-        <p:nvSpPr>
-          <p:cNvPr id="37" name="Text 30"/>
+      <p:pic>
+        <p:nvPicPr>
+          <p:cNvPr id="37" name="Image 5" descr="preencoded.png">    </p:cNvPr>
+          <p:cNvPicPr>
+            <a:picLocks noChangeAspect="1"/>
+          </p:cNvPicPr>
+          <p:nvPr/>
+        </p:nvPicPr>
+        <p:blipFill>
+          <a:blip r:embed="rId6"/>
+          <a:stretch>
+            <a:fillRect/>
+          </a:stretch>
+        </p:blipFill>
+        <p:spPr>
+          <a:xfrm>
+            <a:off x="10911535" y="1207008"/>
+            <a:ext cx="310896" cy="310896"/>
+          </a:xfrm>
+          <a:prstGeom prst="rect">
+            <a:avLst/>
+          </a:prstGeom>
+        </p:spPr>
+      </p:pic>
+      <p:sp>
+        <p:nvSpPr>
+          <p:cNvPr id="38" name="Text 30"/>
           <p:cNvSpPr txBox="1"/>
           <p:nvPr/>
         </p:nvSpPr>
@@ -33692,7 +34076,7 @@
       </p:sp>
       <p:sp>
         <p:nvSpPr>
-          <p:cNvPr id="38" name="Text 31"/>
+          <p:cNvPr id="39" name="Text 31"/>
           <p:cNvSpPr txBox="1"/>
           <p:nvPr/>
         </p:nvSpPr>
@@ -33734,7 +34118,7 @@
       </p:sp>
       <p:sp>
         <p:nvSpPr>
-          <p:cNvPr id="39" name="Text 32"/>
+          <p:cNvPr id="40" name="Text 32"/>
           <p:cNvSpPr txBox="1"/>
           <p:nvPr/>
         </p:nvSpPr>
@@ -33776,7 +34160,7 @@
       </p:sp>
       <p:sp>
         <p:nvSpPr>
-          <p:cNvPr id="40" name="Shape 33"/>
+          <p:cNvPr id="41" name="Shape 33"/>
           <p:cNvSpPr/>
           <p:nvPr/>
         </p:nvSpPr>
@@ -33803,73 +34187,7 @@
       </p:sp>
       <p:pic>
         <p:nvPicPr>
-          <p:cNvPr id="41" name="Image 5" descr="preencoded.png">    </p:cNvPr>
-          <p:cNvPicPr>
-            <a:picLocks noChangeAspect="1"/>
-          </p:cNvPicPr>
-          <p:nvPr/>
-        </p:nvPicPr>
-        <p:blipFill>
-          <a:blip r:embed="rId6"/>
-          <a:stretch>
-            <a:fillRect/>
-          </a:stretch>
-        </p:blipFill>
-        <p:spPr>
-          <a:xfrm>
-            <a:off x="457200" y="3584448"/>
-            <a:ext cx="274320" cy="274320"/>
-          </a:xfrm>
-          <a:prstGeom prst="rect">
-            <a:avLst/>
-          </a:prstGeom>
-        </p:spPr>
-      </p:pic>
-      <p:sp>
-        <p:nvSpPr>
-          <p:cNvPr id="42" name="Text 34"/>
-          <p:cNvSpPr txBox="1"/>
-          <p:nvPr/>
-        </p:nvSpPr>
-        <p:spPr>
-          <a:xfrm>
-            <a:off x="822960" y="3566160"/>
-            <a:ext cx="6583680" cy="310896"/>
-          </a:xfrm>
-          <a:prstGeom prst="rect">
-            <a:avLst/>
-          </a:prstGeom>
-          <a:noFill/>
-          <a:ln/>
-        </p:spPr>
-        <p:txBody>
-          <a:bodyPr wrap="square" lIns="0" tIns="0" rIns="0" bIns="0" rtlCol="0" anchor="ctr"/>
-          <a:lstStyle/>
-          <a:p>
-            <a:pPr algn="l" indent="0" marL="0">
-              <a:lnSpc>
-                <a:spcPct val="95000"/>
-              </a:lnSpc>
-              <a:buNone/>
-            </a:pPr>
-            <a:r>
-              <a:rPr lang="en-US" sz="1300" b="1" dirty="0">
-                <a:solidFill>
-                  <a:srgbClr val="FF812A"/>
-                </a:solidFill>
-                <a:latin typeface="Bahnschrift SemiCondensed" pitchFamily="34" charset="0"/>
-                <a:ea typeface="Bahnschrift SemiCondensed" pitchFamily="34" charset="-122"/>
-                <a:cs typeface="Bahnschrift SemiCondensed" pitchFamily="34" charset="-120"/>
-              </a:rPr>
-              <a:t>Критерий полноценного performance-теста</a:t>
-            </a:r>
-            <a:endParaRPr lang="en-US" sz="1300" dirty="0"/>
-          </a:p>
-        </p:txBody>
-      </p:sp>
-      <p:pic>
-        <p:nvPicPr>
-          <p:cNvPr id="43" name="Image 6" descr="preencoded.png">    </p:cNvPr>
+          <p:cNvPr id="42" name="Image 6" descr="preencoded.png">    </p:cNvPr>
           <p:cNvPicPr>
             <a:picLocks noChangeAspect="1"/>
           </p:cNvPicPr>
@@ -33883,8 +34201,8 @@
         </p:blipFill>
         <p:spPr>
           <a:xfrm>
-            <a:off x="548640" y="4009644"/>
-            <a:ext cx="164592" cy="164592"/>
+            <a:off x="457200" y="3584448"/>
+            <a:ext cx="274320" cy="274320"/>
           </a:xfrm>
           <a:prstGeom prst="rect">
             <a:avLst/>
@@ -33893,49 +34211,49 @@
       </p:pic>
       <p:sp>
         <p:nvSpPr>
-          <p:cNvPr id="44" name="Text 35"/>
-          <p:cNvSpPr txBox="1"/>
-          <p:nvPr/>
-        </p:nvSpPr>
-        <p:spPr>
-          <a:xfrm>
-            <a:off x="822960" y="3950208"/>
-            <a:ext cx="6583680" cy="283464"/>
-          </a:xfrm>
-          <a:prstGeom prst="rect">
-            <a:avLst/>
-          </a:prstGeom>
-          <a:noFill/>
-          <a:ln/>
-        </p:spPr>
-        <p:txBody>
-          <a:bodyPr wrap="square" lIns="0" tIns="0" rIns="0" bIns="0" rtlCol="0" anchor="ctr"/>
-          <a:lstStyle/>
-          <a:p>
-            <a:pPr algn="l" indent="0" marL="0">
-              <a:lnSpc>
-                <a:spcPct val="95000"/>
-              </a:lnSpc>
-              <a:buNone/>
-            </a:pPr>
-            <a:r>
-              <a:rPr lang="en-US" sz="1100" dirty="0">
-                <a:solidFill>
-                  <a:srgbClr val="1F2937"/>
-                </a:solidFill>
-                <a:latin typeface="Bahnschrift SemiCondensed" pitchFamily="34" charset="0"/>
-                <a:ea typeface="Bahnschrift SemiCondensed" pitchFamily="34" charset="-122"/>
-                <a:cs typeface="Bahnschrift SemiCondensed" pitchFamily="34" charset="-120"/>
-              </a:rPr>
-              <a:t>задана конфигурация сети и radio capacity</a:t>
-            </a:r>
-            <a:endParaRPr lang="en-US" sz="1100" dirty="0"/>
+          <p:cNvPr id="43" name="Text 34"/>
+          <p:cNvSpPr txBox="1"/>
+          <p:nvPr/>
+        </p:nvSpPr>
+        <p:spPr>
+          <a:xfrm>
+            <a:off x="822960" y="3566160"/>
+            <a:ext cx="6583680" cy="310896"/>
+          </a:xfrm>
+          <a:prstGeom prst="rect">
+            <a:avLst/>
+          </a:prstGeom>
+          <a:noFill/>
+          <a:ln/>
+        </p:spPr>
+        <p:txBody>
+          <a:bodyPr wrap="square" lIns="0" tIns="0" rIns="0" bIns="0" rtlCol="0" anchor="ctr"/>
+          <a:lstStyle/>
+          <a:p>
+            <a:pPr algn="l" indent="0" marL="0">
+              <a:lnSpc>
+                <a:spcPct val="95000"/>
+              </a:lnSpc>
+              <a:buNone/>
+            </a:pPr>
+            <a:r>
+              <a:rPr lang="en-US" sz="1300" b="1" dirty="0">
+                <a:solidFill>
+                  <a:srgbClr val="FF812A"/>
+                </a:solidFill>
+                <a:latin typeface="Bahnschrift SemiCondensed" pitchFamily="34" charset="0"/>
+                <a:ea typeface="Bahnschrift SemiCondensed" pitchFamily="34" charset="-122"/>
+                <a:cs typeface="Bahnschrift SemiCondensed" pitchFamily="34" charset="-120"/>
+              </a:rPr>
+              <a:t>Критерий полноценного performance-теста</a:t>
+            </a:r>
+            <a:endParaRPr lang="en-US" sz="1300" dirty="0"/>
           </a:p>
         </p:txBody>
       </p:sp>
       <p:pic>
         <p:nvPicPr>
-          <p:cNvPr id="45" name="Image 7" descr="preencoded.png">    </p:cNvPr>
+          <p:cNvPr id="44" name="Image 7" descr="preencoded.png">    </p:cNvPr>
           <p:cNvPicPr>
             <a:picLocks noChangeAspect="1"/>
           </p:cNvPicPr>
@@ -33949,7 +34267,7 @@
         </p:blipFill>
         <p:spPr>
           <a:xfrm>
-            <a:off x="548640" y="4293108"/>
+            <a:off x="548640" y="4009644"/>
             <a:ext cx="164592" cy="164592"/>
           </a:xfrm>
           <a:prstGeom prst="rect">
@@ -33959,13 +34277,13 @@
       </p:pic>
       <p:sp>
         <p:nvSpPr>
-          <p:cNvPr id="46" name="Text 36"/>
-          <p:cNvSpPr txBox="1"/>
-          <p:nvPr/>
-        </p:nvSpPr>
-        <p:spPr>
-          <a:xfrm>
-            <a:off x="822960" y="4233672"/>
+          <p:cNvPr id="45" name="Text 35"/>
+          <p:cNvSpPr txBox="1"/>
+          <p:nvPr/>
+        </p:nvSpPr>
+        <p:spPr>
+          <a:xfrm>
+            <a:off x="822960" y="3950208"/>
             <a:ext cx="6583680" cy="283464"/>
           </a:xfrm>
           <a:prstGeom prst="rect">
@@ -33993,7 +34311,7 @@
                 <a:ea typeface="Bahnschrift SemiCondensed" pitchFamily="34" charset="-122"/>
                 <a:cs typeface="Bahnschrift SemiCondensed" pitchFamily="34" charset="-120"/>
               </a:rPr>
-              <a:t>активированы нужные MIMO и CA режимы</a:t>
+              <a:t>задана конфигурация сети и radio capacity</a:t>
             </a:r>
             <a:endParaRPr lang="en-US" sz="1100" dirty="0"/>
           </a:p>
@@ -34001,7 +34319,7 @@
       </p:sp>
       <p:pic>
         <p:nvPicPr>
-          <p:cNvPr id="47" name="Image 8" descr="preencoded.png">    </p:cNvPr>
+          <p:cNvPr id="46" name="Image 8" descr="preencoded.png">    </p:cNvPr>
           <p:cNvPicPr>
             <a:picLocks noChangeAspect="1"/>
           </p:cNvPicPr>
@@ -34015,7 +34333,7 @@
         </p:blipFill>
         <p:spPr>
           <a:xfrm>
-            <a:off x="548640" y="4576572"/>
+            <a:off x="548640" y="4293108"/>
             <a:ext cx="164592" cy="164592"/>
           </a:xfrm>
           <a:prstGeom prst="rect">
@@ -34025,13 +34343,13 @@
       </p:pic>
       <p:sp>
         <p:nvSpPr>
-          <p:cNvPr id="48" name="Text 37"/>
-          <p:cNvSpPr txBox="1"/>
-          <p:nvPr/>
-        </p:nvSpPr>
-        <p:spPr>
-          <a:xfrm>
-            <a:off x="822960" y="4517136"/>
+          <p:cNvPr id="47" name="Text 36"/>
+          <p:cNvSpPr txBox="1"/>
+          <p:nvPr/>
+        </p:nvSpPr>
+        <p:spPr>
+          <a:xfrm>
+            <a:off x="822960" y="4233672"/>
             <a:ext cx="6583680" cy="283464"/>
           </a:xfrm>
           <a:prstGeom prst="rect">
@@ -34059,7 +34377,7 @@
                 <a:ea typeface="Bahnschrift SemiCondensed" pitchFamily="34" charset="-122"/>
                 <a:cs typeface="Bahnschrift SemiCondensed" pitchFamily="34" charset="-120"/>
               </a:rPr>
-              <a:t>создан контролируемый DL / UL traffic profile</a:t>
+              <a:t>активированы нужные MIMO и CA режимы</a:t>
             </a:r>
             <a:endParaRPr lang="en-US" sz="1100" dirty="0"/>
           </a:p>
@@ -34067,7 +34385,7 @@
       </p:sp>
       <p:pic>
         <p:nvPicPr>
-          <p:cNvPr id="49" name="Image 9" descr="preencoded.png">    </p:cNvPr>
+          <p:cNvPr id="48" name="Image 9" descr="preencoded.png">    </p:cNvPr>
           <p:cNvPicPr>
             <a:picLocks noChangeAspect="1"/>
           </p:cNvPicPr>
@@ -34081,7 +34399,7 @@
         </p:blipFill>
         <p:spPr>
           <a:xfrm>
-            <a:off x="548640" y="4860036"/>
+            <a:off x="548640" y="4576572"/>
             <a:ext cx="164592" cy="164592"/>
           </a:xfrm>
           <a:prstGeom prst="rect">
@@ -34091,13 +34409,13 @@
       </p:pic>
       <p:sp>
         <p:nvSpPr>
-          <p:cNvPr id="50" name="Text 38"/>
-          <p:cNvSpPr txBox="1"/>
-          <p:nvPr/>
-        </p:nvSpPr>
-        <p:spPr>
-          <a:xfrm>
-            <a:off x="822960" y="4800600"/>
+          <p:cNvPr id="49" name="Text 37"/>
+          <p:cNvSpPr txBox="1"/>
+          <p:nvPr/>
+        </p:nvSpPr>
+        <p:spPr>
+          <a:xfrm>
+            <a:off x="822960" y="4517136"/>
             <a:ext cx="6583680" cy="283464"/>
           </a:xfrm>
           <a:prstGeom prst="rect">
@@ -34125,7 +34443,7 @@
                 <a:ea typeface="Bahnschrift SemiCondensed" pitchFamily="34" charset="-122"/>
                 <a:cs typeface="Bahnschrift SemiCondensed" pitchFamily="34" charset="-120"/>
               </a:rPr>
-              <a:t>радиоканал проверен в ideal и fading conditions</a:t>
+              <a:t>создан контролируемый DL / UL traffic profile</a:t>
             </a:r>
             <a:endParaRPr lang="en-US" sz="1100" dirty="0"/>
           </a:p>
@@ -34133,7 +34451,7 @@
       </p:sp>
       <p:pic>
         <p:nvPicPr>
-          <p:cNvPr id="51" name="Image 10" descr="preencoded.png">    </p:cNvPr>
+          <p:cNvPr id="50" name="Image 10" descr="preencoded.png">    </p:cNvPr>
           <p:cNvPicPr>
             <a:picLocks noChangeAspect="1"/>
           </p:cNvPicPr>
@@ -34147,7 +34465,7 @@
         </p:blipFill>
         <p:spPr>
           <a:xfrm>
-            <a:off x="548640" y="5143500"/>
+            <a:off x="548640" y="4860036"/>
             <a:ext cx="164592" cy="164592"/>
           </a:xfrm>
           <a:prstGeom prst="rect">
@@ -34157,13 +34475,13 @@
       </p:pic>
       <p:sp>
         <p:nvSpPr>
-          <p:cNvPr id="52" name="Text 39"/>
-          <p:cNvSpPr txBox="1"/>
-          <p:nvPr/>
-        </p:nvSpPr>
-        <p:spPr>
-          <a:xfrm>
-            <a:off x="822960" y="5084064"/>
+          <p:cNvPr id="51" name="Text 38"/>
+          <p:cNvSpPr txBox="1"/>
+          <p:nvPr/>
+        </p:nvSpPr>
+        <p:spPr>
+          <a:xfrm>
+            <a:off x="822960" y="4800600"/>
             <a:ext cx="6583680" cy="283464"/>
           </a:xfrm>
           <a:prstGeom prst="rect">
@@ -34191,7 +34509,7 @@
                 <a:ea typeface="Bahnschrift SemiCondensed" pitchFamily="34" charset="-122"/>
                 <a:cs typeface="Bahnschrift SemiCondensed" pitchFamily="34" charset="-120"/>
               </a:rPr>
-              <a:t>собраны protocol trace, packet capture и PHY / RF indicators</a:t>
+              <a:t>радиоканал проверен в ideal и fading conditions</a:t>
             </a:r>
             <a:endParaRPr lang="en-US" sz="1100" dirty="0"/>
           </a:p>
@@ -34199,7 +34517,7 @@
       </p:sp>
       <p:pic>
         <p:nvPicPr>
-          <p:cNvPr id="53" name="Image 11" descr="preencoded.png">    </p:cNvPr>
+          <p:cNvPr id="52" name="Image 11" descr="preencoded.png">    </p:cNvPr>
           <p:cNvPicPr>
             <a:picLocks noChangeAspect="1"/>
           </p:cNvPicPr>
@@ -34213,7 +34531,7 @@
         </p:blipFill>
         <p:spPr>
           <a:xfrm>
-            <a:off x="548640" y="5426964"/>
+            <a:off x="548640" y="5143500"/>
             <a:ext cx="164592" cy="164592"/>
           </a:xfrm>
           <a:prstGeom prst="rect">
@@ -34223,13 +34541,13 @@
       </p:pic>
       <p:sp>
         <p:nvSpPr>
-          <p:cNvPr id="54" name="Text 40"/>
-          <p:cNvSpPr txBox="1"/>
-          <p:nvPr/>
-        </p:nvSpPr>
-        <p:spPr>
-          <a:xfrm>
-            <a:off x="822960" y="5367528"/>
+          <p:cNvPr id="53" name="Text 39"/>
+          <p:cNvSpPr txBox="1"/>
+          <p:nvPr/>
+        </p:nvSpPr>
+        <p:spPr>
+          <a:xfrm>
+            <a:off x="822960" y="5084064"/>
             <a:ext cx="6583680" cy="283464"/>
           </a:xfrm>
           <a:prstGeom prst="rect">
@@ -34257,7 +34575,7 @@
                 <a:ea typeface="Bahnschrift SemiCondensed" pitchFamily="34" charset="-122"/>
                 <a:cs typeface="Bahnschrift SemiCondensed" pitchFamily="34" charset="-120"/>
               </a:rPr>
-              <a:t>разница PHY throughput, user throughput и application goodput объяснена</a:t>
+              <a:t>собраны protocol trace, packet capture и PHY / RF indicators</a:t>
             </a:r>
             <a:endParaRPr lang="en-US" sz="1100" dirty="0"/>
           </a:p>
@@ -34265,7 +34583,7 @@
       </p:sp>
       <p:pic>
         <p:nvPicPr>
-          <p:cNvPr id="55" name="Image 12" descr="preencoded.png">    </p:cNvPr>
+          <p:cNvPr id="54" name="Image 12" descr="preencoded.png">    </p:cNvPr>
           <p:cNvPicPr>
             <a:picLocks noChangeAspect="1"/>
           </p:cNvPicPr>
@@ -34279,6 +34597,72 @@
         </p:blipFill>
         <p:spPr>
           <a:xfrm>
+            <a:off x="548640" y="5426964"/>
+            <a:ext cx="164592" cy="164592"/>
+          </a:xfrm>
+          <a:prstGeom prst="rect">
+            <a:avLst/>
+          </a:prstGeom>
+        </p:spPr>
+      </p:pic>
+      <p:sp>
+        <p:nvSpPr>
+          <p:cNvPr id="55" name="Text 40"/>
+          <p:cNvSpPr txBox="1"/>
+          <p:nvPr/>
+        </p:nvSpPr>
+        <p:spPr>
+          <a:xfrm>
+            <a:off x="822960" y="5367528"/>
+            <a:ext cx="6583680" cy="283464"/>
+          </a:xfrm>
+          <a:prstGeom prst="rect">
+            <a:avLst/>
+          </a:prstGeom>
+          <a:noFill/>
+          <a:ln/>
+        </p:spPr>
+        <p:txBody>
+          <a:bodyPr wrap="square" lIns="0" tIns="0" rIns="0" bIns="0" rtlCol="0" anchor="ctr"/>
+          <a:lstStyle/>
+          <a:p>
+            <a:pPr algn="l" indent="0" marL="0">
+              <a:lnSpc>
+                <a:spcPct val="95000"/>
+              </a:lnSpc>
+              <a:buNone/>
+            </a:pPr>
+            <a:r>
+              <a:rPr lang="en-US" sz="1100" dirty="0">
+                <a:solidFill>
+                  <a:srgbClr val="1F2937"/>
+                </a:solidFill>
+                <a:latin typeface="Bahnschrift SemiCondensed" pitchFamily="34" charset="0"/>
+                <a:ea typeface="Bahnschrift SemiCondensed" pitchFamily="34" charset="-122"/>
+                <a:cs typeface="Bahnschrift SemiCondensed" pitchFamily="34" charset="-120"/>
+              </a:rPr>
+              <a:t>разница PHY throughput, user throughput и application goodput объяснена</a:t>
+            </a:r>
+            <a:endParaRPr lang="en-US" sz="1100" dirty="0"/>
+          </a:p>
+        </p:txBody>
+      </p:sp>
+      <p:pic>
+        <p:nvPicPr>
+          <p:cNvPr id="56" name="Image 13" descr="preencoded.png">    </p:cNvPr>
+          <p:cNvPicPr>
+            <a:picLocks noChangeAspect="1"/>
+          </p:cNvPicPr>
+          <p:nvPr/>
+        </p:nvPicPr>
+        <p:blipFill>
+          <a:blip r:embed="rId14"/>
+          <a:stretch>
+            <a:fillRect/>
+          </a:stretch>
+        </p:blipFill>
+        <p:spPr>
+          <a:xfrm>
             <a:off x="548640" y="5710428"/>
             <a:ext cx="164592" cy="164592"/>
           </a:xfrm>
@@ -34289,7 +34673,7 @@
       </p:pic>
       <p:sp>
         <p:nvSpPr>
-          <p:cNvPr id="56" name="Text 41"/>
+          <p:cNvPr id="57" name="Text 41"/>
           <p:cNvSpPr txBox="1"/>
           <p:nvPr/>
         </p:nvSpPr>
@@ -34331,7 +34715,7 @@
       </p:sp>
       <p:sp>
         <p:nvSpPr>
-          <p:cNvPr id="57" name="Shape 42"/>
+          <p:cNvPr id="58" name="Shape 42"/>
           <p:cNvSpPr/>
           <p:nvPr/>
         </p:nvSpPr>
@@ -34358,7 +34742,7 @@
       </p:sp>
       <p:sp>
         <p:nvSpPr>
-          <p:cNvPr id="58" name="Text 43"/>
+          <p:cNvPr id="59" name="Text 43"/>
           <p:cNvSpPr txBox="1"/>
           <p:nvPr/>
         </p:nvSpPr>
@@ -34400,7 +34784,7 @@
       </p:sp>
       <p:sp>
         <p:nvSpPr>
-          <p:cNvPr id="59" name="Shape 44"/>
+          <p:cNvPr id="60" name="Shape 44"/>
           <p:cNvSpPr/>
           <p:nvPr/>
         </p:nvSpPr>
@@ -34427,7 +34811,7 @@
       </p:sp>
       <p:sp>
         <p:nvSpPr>
-          <p:cNvPr id="60" name="Text 45"/>
+          <p:cNvPr id="61" name="Text 45"/>
           <p:cNvSpPr txBox="1"/>
           <p:nvPr/>
         </p:nvSpPr>
@@ -34469,7 +34853,7 @@
       </p:sp>
       <p:sp>
         <p:nvSpPr>
-          <p:cNvPr id="61" name="Shape 46"/>
+          <p:cNvPr id="62" name="Shape 46"/>
           <p:cNvSpPr/>
           <p:nvPr/>
         </p:nvSpPr>
@@ -34494,7 +34878,7 @@
       </p:sp>
       <p:sp>
         <p:nvSpPr>
-          <p:cNvPr id="62" name="Shape 47"/>
+          <p:cNvPr id="63" name="Shape 47"/>
           <p:cNvSpPr/>
           <p:nvPr/>
         </p:nvSpPr>
@@ -34521,7 +34905,7 @@
       </p:sp>
       <p:sp>
         <p:nvSpPr>
-          <p:cNvPr id="63" name="Text 48"/>
+          <p:cNvPr id="64" name="Text 48"/>
           <p:cNvSpPr txBox="1"/>
           <p:nvPr/>
         </p:nvSpPr>
@@ -34563,7 +34947,7 @@
       </p:sp>
       <p:sp>
         <p:nvSpPr>
-          <p:cNvPr id="64" name="Shape 49"/>
+          <p:cNvPr id="65" name="Shape 49"/>
           <p:cNvSpPr/>
           <p:nvPr/>
         </p:nvSpPr>
@@ -34588,7 +34972,7 @@
       </p:sp>
       <p:sp>
         <p:nvSpPr>
-          <p:cNvPr id="65" name="Shape 50"/>
+          <p:cNvPr id="66" name="Shape 50"/>
           <p:cNvSpPr/>
           <p:nvPr/>
         </p:nvSpPr>
@@ -34615,7 +34999,7 @@
       </p:sp>
       <p:sp>
         <p:nvSpPr>
-          <p:cNvPr id="66" name="Text 51"/>
+          <p:cNvPr id="67" name="Text 51"/>
           <p:cNvSpPr txBox="1"/>
           <p:nvPr/>
         </p:nvSpPr>
@@ -34657,7 +35041,7 @@
       </p:sp>
       <p:sp>
         <p:nvSpPr>
-          <p:cNvPr id="67" name="Shape 52"/>
+          <p:cNvPr id="68" name="Shape 52"/>
           <p:cNvSpPr/>
           <p:nvPr/>
         </p:nvSpPr>
@@ -34682,7 +35066,7 @@
       </p:sp>
       <p:sp>
         <p:nvSpPr>
-          <p:cNvPr id="68" name="Shape 53"/>
+          <p:cNvPr id="69" name="Shape 53"/>
           <p:cNvSpPr/>
           <p:nvPr/>
         </p:nvSpPr>
@@ -34709,7 +35093,7 @@
       </p:sp>
       <p:sp>
         <p:nvSpPr>
-          <p:cNvPr id="69" name="Text 54"/>
+          <p:cNvPr id="70" name="Text 54"/>
           <p:cNvSpPr txBox="1"/>
           <p:nvPr/>
         </p:nvSpPr>
@@ -34751,7 +35135,7 @@
       </p:sp>
       <p:sp>
         <p:nvSpPr>
-          <p:cNvPr id="70" name="Shape 55"/>
+          <p:cNvPr id="71" name="Shape 55"/>
           <p:cNvSpPr/>
           <p:nvPr/>
         </p:nvSpPr>
@@ -34774,95 +35158,7 @@
       </p:sp>
       <p:pic>
         <p:nvPicPr>
-          <p:cNvPr id="71" name="Image 13" descr="preencoded.png">    </p:cNvPr>
-          <p:cNvPicPr>
-            <a:picLocks noChangeAspect="1"/>
-          </p:cNvPicPr>
-          <p:nvPr/>
-        </p:nvPicPr>
-        <p:blipFill>
-          <a:blip r:embed="rId14"/>
-          <a:stretch>
-            <a:fillRect/>
-          </a:stretch>
-        </p:blipFill>
-        <p:spPr>
-          <a:xfrm>
-            <a:off x="10789920" y="4270248"/>
-            <a:ext cx="548640" cy="548640"/>
-          </a:xfrm>
-          <a:prstGeom prst="rect">
-            <a:avLst/>
-          </a:prstGeom>
-        </p:spPr>
-      </p:pic>
-      <p:sp>
-        <p:nvSpPr>
-          <p:cNvPr id="72" name="Text 56"/>
-          <p:cNvSpPr txBox="1"/>
-          <p:nvPr/>
-        </p:nvSpPr>
-        <p:spPr>
-          <a:xfrm>
-            <a:off x="10607040" y="4910328"/>
-            <a:ext cx="1218895" cy="822960"/>
-          </a:xfrm>
-          <a:prstGeom prst="rect">
-            <a:avLst/>
-          </a:prstGeom>
-          <a:noFill/>
-          <a:ln/>
-        </p:spPr>
-        <p:txBody>
-          <a:bodyPr wrap="square" lIns="0" tIns="0" rIns="0" bIns="0" rtlCol="0" anchor="t"/>
-          <a:lstStyle/>
-          <a:p>
-            <a:pPr algn="ctr" indent="0" marL="0">
-              <a:lnSpc>
-                <a:spcPct val="95000"/>
-              </a:lnSpc>
-              <a:buNone/>
-            </a:pPr>
-            <a:r>
-              <a:rPr lang="en-US" sz="1200" b="1" dirty="0">
-                <a:solidFill>
-                  <a:srgbClr val="1F2937"/>
-                </a:solidFill>
-                <a:latin typeface="Bahnschrift SemiCondensed" pitchFamily="34" charset="0"/>
-                <a:ea typeface="Bahnschrift SemiCondensed" pitchFamily="34" charset="-122"/>
-                <a:cs typeface="Bahnschrift SemiCondensed" pitchFamily="34" charset="-120"/>
-              </a:rPr>
-              <a:t>Разница между уровнями объяснена</a:t>
-            </a:r>
-            <a:endParaRPr lang="en-US" sz="1200" dirty="0"/>
-          </a:p>
-        </p:txBody>
-      </p:sp>
-      <p:sp>
-        <p:nvSpPr>
-          <p:cNvPr id="73" name="Shape 57"/>
-          <p:cNvSpPr/>
-          <p:nvPr/>
-        </p:nvSpPr>
-        <p:spPr>
-          <a:xfrm>
-            <a:off x="274320" y="6163056"/>
-            <a:ext cx="11643055" cy="548640"/>
-          </a:xfrm>
-          <a:prstGeom prst="roundRect">
-            <a:avLst>
-              <a:gd name="adj" fmla="val 16667"/>
-            </a:avLst>
-          </a:prstGeom>
-          <a:solidFill>
-            <a:srgbClr val="534EE6"/>
-          </a:solidFill>
-          <a:ln/>
-        </p:spPr>
-      </p:sp>
-      <p:pic>
-        <p:nvPicPr>
-          <p:cNvPr id="74" name="Image 14" descr="preencoded.png">    </p:cNvPr>
+          <p:cNvPr id="72" name="Image 14" descr="preencoded.png">    </p:cNvPr>
           <p:cNvPicPr>
             <a:picLocks noChangeAspect="1"/>
           </p:cNvPicPr>
@@ -34876,6 +35172,94 @@
         </p:blipFill>
         <p:spPr>
           <a:xfrm>
+            <a:off x="10789920" y="4270248"/>
+            <a:ext cx="548640" cy="548640"/>
+          </a:xfrm>
+          <a:prstGeom prst="rect">
+            <a:avLst/>
+          </a:prstGeom>
+        </p:spPr>
+      </p:pic>
+      <p:sp>
+        <p:nvSpPr>
+          <p:cNvPr id="73" name="Text 56"/>
+          <p:cNvSpPr txBox="1"/>
+          <p:nvPr/>
+        </p:nvSpPr>
+        <p:spPr>
+          <a:xfrm>
+            <a:off x="10607040" y="4910328"/>
+            <a:ext cx="1218895" cy="822960"/>
+          </a:xfrm>
+          <a:prstGeom prst="rect">
+            <a:avLst/>
+          </a:prstGeom>
+          <a:noFill/>
+          <a:ln/>
+        </p:spPr>
+        <p:txBody>
+          <a:bodyPr wrap="square" lIns="0" tIns="0" rIns="0" bIns="0" rtlCol="0" anchor="t"/>
+          <a:lstStyle/>
+          <a:p>
+            <a:pPr algn="ctr" indent="0" marL="0">
+              <a:lnSpc>
+                <a:spcPct val="95000"/>
+              </a:lnSpc>
+              <a:buNone/>
+            </a:pPr>
+            <a:r>
+              <a:rPr lang="en-US" sz="1200" b="1" dirty="0">
+                <a:solidFill>
+                  <a:srgbClr val="1F2937"/>
+                </a:solidFill>
+                <a:latin typeface="Bahnschrift SemiCondensed" pitchFamily="34" charset="0"/>
+                <a:ea typeface="Bahnschrift SemiCondensed" pitchFamily="34" charset="-122"/>
+                <a:cs typeface="Bahnschrift SemiCondensed" pitchFamily="34" charset="-120"/>
+              </a:rPr>
+              <a:t>Разница между уровнями объяснена</a:t>
+            </a:r>
+            <a:endParaRPr lang="en-US" sz="1200" dirty="0"/>
+          </a:p>
+        </p:txBody>
+      </p:sp>
+      <p:sp>
+        <p:nvSpPr>
+          <p:cNvPr id="74" name="Shape 57"/>
+          <p:cNvSpPr/>
+          <p:nvPr/>
+        </p:nvSpPr>
+        <p:spPr>
+          <a:xfrm>
+            <a:off x="274320" y="6163056"/>
+            <a:ext cx="11643055" cy="548640"/>
+          </a:xfrm>
+          <a:prstGeom prst="roundRect">
+            <a:avLst>
+              <a:gd name="adj" fmla="val 16667"/>
+            </a:avLst>
+          </a:prstGeom>
+          <a:solidFill>
+            <a:srgbClr val="534EE6"/>
+          </a:solidFill>
+          <a:ln/>
+        </p:spPr>
+      </p:sp>
+      <p:pic>
+        <p:nvPicPr>
+          <p:cNvPr id="75" name="Image 15" descr="preencoded.png">    </p:cNvPr>
+          <p:cNvPicPr>
+            <a:picLocks noChangeAspect="1"/>
+          </p:cNvPicPr>
+          <p:nvPr/>
+        </p:nvPicPr>
+        <p:blipFill>
+          <a:blip r:embed="rId16"/>
+          <a:stretch>
+            <a:fillRect/>
+          </a:stretch>
+        </p:blipFill>
+        <p:spPr>
+          <a:xfrm>
             <a:off x="548640" y="6254496"/>
             <a:ext cx="365760" cy="365760"/>
           </a:xfrm>
@@ -34886,7 +35270,7 @@
       </p:pic>
       <p:sp>
         <p:nvSpPr>
-          <p:cNvPr id="75" name="Text 58"/>
+          <p:cNvPr id="76" name="Text 58"/>
           <p:cNvSpPr txBox="1"/>
           <p:nvPr/>
         </p:nvSpPr>

</xml_diff>